<commit_message>
Presentazione cap. 02: slide 12 su due colonne
Il contenuto della slide "Casi raggruppati e break" ora sta sopra il piè di pagina.

Co-Authored-By: Claude Opus 5.5 <noreply@anthropic.com>
Claude-Session: https://claude.ai/code/session_01McKApmha1SUQudA1gmsZp2
</commit_message>
<xml_diff>
--- a/00-Documentazione/Linguaggio-C-02-Il-Controllo-del-Flusso.pptx
+++ b/00-Documentazione/Linguaggio-C-02-Il-Controllo-del-Flusso.pptx
@@ -5794,8 +5794,8 @@
         </p:nvSpPr>
         <p:spPr>
           <a:xfrm>
-            <a:off x="406390" y="72974"/>
-            <a:ext cx="11378915" cy="428923"/>
+            <a:off x="406390" y="485865"/>
+            <a:ext cx="11378915" cy="446980"/>
           </a:xfrm>
           <a:prstGeom prst="rect">
             <a:avLst/>
@@ -5814,7 +5814,7 @@
               <a:buNone/>
             </a:pPr>
             <a:r>
-              <a:rPr lang="en-US" sz="3050" b="1" dirty="0">
+              <a:rPr lang="en-US" sz="3200" b="1" dirty="0">
                 <a:solidFill>
                   <a:srgbClr val="1F1E1E"/>
                 </a:solidFill>
@@ -5824,66 +5824,24 @@
               </a:rPr>
               <a:t>Casi Raggruppati e break</a:t>
             </a:r>
-            <a:endParaRPr lang="en-US" sz="3050" dirty="0"/>
+            <a:endParaRPr lang="en-US" sz="3200" dirty="0"/>
           </a:p>
         </p:txBody>
       </p:sp>
       <p:sp>
         <p:nvSpPr>
-          <p:cNvPr id="3" name="Text 1"/>
+          <p:cNvPr id="3" name="Shape 1"/>
           <p:cNvSpPr/>
           <p:nvPr/>
         </p:nvSpPr>
         <p:spPr>
           <a:xfrm>
-            <a:off x="406390" y="651518"/>
-            <a:ext cx="11785305" cy="233859"/>
-          </a:xfrm>
-          <a:prstGeom prst="rect">
-            <a:avLst/>
-          </a:prstGeom>
-          <a:noFill/>
-          <a:ln/>
-        </p:spPr>
-        <p:txBody>
-          <a:bodyPr wrap="none" lIns="0" tIns="0" rIns="0" bIns="0" rtlCol="0" anchor="t"/>
-          <a:lstStyle/>
-          <a:p>
-            <a:pPr algn="l" indent="0" marL="0">
-              <a:lnSpc>
-                <a:spcPct val="114000"/>
-              </a:lnSpc>
-              <a:buNone/>
-            </a:pPr>
-            <a:r>
-              <a:rPr lang="en-US" sz="1350" dirty="0">
-                <a:solidFill>
-                  <a:srgbClr val="3B3535"/>
-                </a:solidFill>
-                <a:latin typeface="Verdana" pitchFamily="34" charset="0"/>
-                <a:ea typeface="Verdana" pitchFamily="34" charset="-122"/>
-                <a:cs typeface="Verdana" pitchFamily="34" charset="-120"/>
-              </a:rPr>
-              <a:t>Senza break l'esecuzione prosegue nel case successivo (fall-through). Si sfrutta per raggruppare i valori:</a:t>
-            </a:r>
-            <a:endParaRPr lang="en-US" sz="1350" dirty="0"/>
-          </a:p>
-        </p:txBody>
-      </p:sp>
-      <p:sp>
-        <p:nvSpPr>
-          <p:cNvPr id="4" name="Shape 2"/>
-          <p:cNvSpPr/>
-          <p:nvPr/>
-        </p:nvSpPr>
-        <p:spPr>
-          <a:xfrm>
-            <a:off x="406390" y="1069082"/>
-            <a:ext cx="11378915" cy="4706739"/>
+            <a:off x="406390" y="1287859"/>
+            <a:ext cx="5537061" cy="4906963"/>
           </a:xfrm>
           <a:prstGeom prst="roundRect">
             <a:avLst>
-              <a:gd name="adj" fmla="val 243"/>
+              <a:gd name="adj" fmla="val 233"/>
             </a:avLst>
           </a:prstGeom>
           <a:solidFill>
@@ -5894,14 +5852,14 @@
       </p:sp>
       <p:sp>
         <p:nvSpPr>
-          <p:cNvPr id="5" name="Text 3"/>
+          <p:cNvPr id="4" name="Text 2"/>
           <p:cNvSpPr/>
           <p:nvPr/>
         </p:nvSpPr>
         <p:spPr>
           <a:xfrm>
-            <a:off x="611073" y="1239639"/>
-            <a:ext cx="10969549" cy="4365625"/>
+            <a:off x="619705" y="1465977"/>
+            <a:ext cx="5110432" cy="4551363"/>
           </a:xfrm>
           <a:prstGeom prst="rect">
             <a:avLst/>
@@ -5922,7 +5880,7 @@
               <a:buNone/>
             </a:pPr>
             <a:r>
-              <a:rPr lang="en-US" sz="1350" dirty="0">
+              <a:rPr lang="en-US" sz="1400" dirty="0">
                 <a:solidFill>
                   <a:srgbClr val="24292E"/>
                 </a:solidFill>
@@ -5932,7 +5890,7 @@
               </a:rPr>
               <a:t>switch (giorno) {</a:t>
             </a:r>
-            <a:endParaRPr lang="en-US" sz="1350" dirty="0"/>
+            <a:endParaRPr lang="en-US" sz="1400" dirty="0"/>
           </a:p>
           <a:p>
             <a:pPr algn="l" indent="0" marL="0">
@@ -5942,7 +5900,7 @@
               <a:buNone/>
             </a:pPr>
             <a:r>
-              <a:rPr lang="en-US" sz="1350" dirty="0">
+              <a:rPr lang="en-US" sz="1400" dirty="0">
                 <a:solidFill>
                   <a:srgbClr val="24292E"/>
                 </a:solidFill>
@@ -5952,7 +5910,7 @@
               </a:rPr>
               <a:t>    case 1:</a:t>
             </a:r>
-            <a:endParaRPr lang="en-US" sz="1350" dirty="0"/>
+            <a:endParaRPr lang="en-US" sz="1400" dirty="0"/>
           </a:p>
           <a:p>
             <a:pPr algn="l" indent="0" marL="0">
@@ -5962,7 +5920,7 @@
               <a:buNone/>
             </a:pPr>
             <a:r>
-              <a:rPr lang="en-US" sz="1350" dirty="0">
+              <a:rPr lang="en-US" sz="1400" dirty="0">
                 <a:solidFill>
                   <a:srgbClr val="24292E"/>
                 </a:solidFill>
@@ -5972,7 +5930,7 @@
               </a:rPr>
               <a:t>    case 2:</a:t>
             </a:r>
-            <a:endParaRPr lang="en-US" sz="1350" dirty="0"/>
+            <a:endParaRPr lang="en-US" sz="1400" dirty="0"/>
           </a:p>
           <a:p>
             <a:pPr algn="l" indent="0" marL="0">
@@ -5982,7 +5940,7 @@
               <a:buNone/>
             </a:pPr>
             <a:r>
-              <a:rPr lang="en-US" sz="1350" dirty="0">
+              <a:rPr lang="en-US" sz="1400" dirty="0">
                 <a:solidFill>
                   <a:srgbClr val="24292E"/>
                 </a:solidFill>
@@ -5992,7 +5950,7 @@
               </a:rPr>
               <a:t>    case 3:</a:t>
             </a:r>
-            <a:endParaRPr lang="en-US" sz="1350" dirty="0"/>
+            <a:endParaRPr lang="en-US" sz="1400" dirty="0"/>
           </a:p>
           <a:p>
             <a:pPr algn="l" indent="0" marL="0">
@@ -6002,7 +5960,7 @@
               <a:buNone/>
             </a:pPr>
             <a:r>
-              <a:rPr lang="en-US" sz="1350" dirty="0">
+              <a:rPr lang="en-US" sz="1400" dirty="0">
                 <a:solidFill>
                   <a:srgbClr val="24292E"/>
                 </a:solidFill>
@@ -6012,7 +5970,7 @@
               </a:rPr>
               <a:t>    case 4:</a:t>
             </a:r>
-            <a:endParaRPr lang="en-US" sz="1350" dirty="0"/>
+            <a:endParaRPr lang="en-US" sz="1400" dirty="0"/>
           </a:p>
           <a:p>
             <a:pPr algn="l" indent="0" marL="0">
@@ -6022,7 +5980,7 @@
               <a:buNone/>
             </a:pPr>
             <a:r>
-              <a:rPr lang="en-US" sz="1350" dirty="0">
+              <a:rPr lang="en-US" sz="1400" dirty="0">
                 <a:solidFill>
                   <a:srgbClr val="24292E"/>
                 </a:solidFill>
@@ -6032,7 +5990,7 @@
               </a:rPr>
               <a:t>    case 5:</a:t>
             </a:r>
-            <a:endParaRPr lang="en-US" sz="1350" dirty="0"/>
+            <a:endParaRPr lang="en-US" sz="1400" dirty="0"/>
           </a:p>
           <a:p>
             <a:pPr algn="l" indent="0" marL="0">
@@ -6042,7 +6000,7 @@
               <a:buNone/>
             </a:pPr>
             <a:r>
-              <a:rPr lang="en-US" sz="1350" dirty="0">
+              <a:rPr lang="en-US" sz="1400" dirty="0">
                 <a:solidFill>
                   <a:srgbClr val="24292E"/>
                 </a:solidFill>
@@ -6052,7 +6010,7 @@
               </a:rPr>
               <a:t>        printf("giorno feriale\n");</a:t>
             </a:r>
-            <a:endParaRPr lang="en-US" sz="1350" dirty="0"/>
+            <a:endParaRPr lang="en-US" sz="1400" dirty="0"/>
           </a:p>
           <a:p>
             <a:pPr algn="l" indent="0" marL="0">
@@ -6062,7 +6020,7 @@
               <a:buNone/>
             </a:pPr>
             <a:r>
-              <a:rPr lang="en-US" sz="1350" dirty="0">
+              <a:rPr lang="en-US" sz="1400" dirty="0">
                 <a:solidFill>
                   <a:srgbClr val="24292E"/>
                 </a:solidFill>
@@ -6072,7 +6030,7 @@
               </a:rPr>
               <a:t>        break;</a:t>
             </a:r>
-            <a:endParaRPr lang="en-US" sz="1350" dirty="0"/>
+            <a:endParaRPr lang="en-US" sz="1400" dirty="0"/>
           </a:p>
           <a:p>
             <a:pPr algn="l" indent="0" marL="0">
@@ -6082,7 +6040,7 @@
               <a:buNone/>
             </a:pPr>
             <a:r>
-              <a:rPr lang="en-US" sz="1350" dirty="0">
+              <a:rPr lang="en-US" sz="1400" dirty="0">
                 <a:solidFill>
                   <a:srgbClr val="24292E"/>
                 </a:solidFill>
@@ -6092,7 +6050,7 @@
               </a:rPr>
               <a:t>    case 6:</a:t>
             </a:r>
-            <a:endParaRPr lang="en-US" sz="1350" dirty="0"/>
+            <a:endParaRPr lang="en-US" sz="1400" dirty="0"/>
           </a:p>
           <a:p>
             <a:pPr algn="l" indent="0" marL="0">
@@ -6102,7 +6060,7 @@
               <a:buNone/>
             </a:pPr>
             <a:r>
-              <a:rPr lang="en-US" sz="1350" dirty="0">
+              <a:rPr lang="en-US" sz="1400" dirty="0">
                 <a:solidFill>
                   <a:srgbClr val="24292E"/>
                 </a:solidFill>
@@ -6112,7 +6070,7 @@
               </a:rPr>
               <a:t>    case 7:</a:t>
             </a:r>
-            <a:endParaRPr lang="en-US" sz="1350" dirty="0"/>
+            <a:endParaRPr lang="en-US" sz="1400" dirty="0"/>
           </a:p>
           <a:p>
             <a:pPr algn="l" indent="0" marL="0">
@@ -6122,7 +6080,7 @@
               <a:buNone/>
             </a:pPr>
             <a:r>
-              <a:rPr lang="en-US" sz="1350" dirty="0">
+              <a:rPr lang="en-US" sz="1400" dirty="0">
                 <a:solidFill>
                   <a:srgbClr val="24292E"/>
                 </a:solidFill>
@@ -6132,7 +6090,7 @@
               </a:rPr>
               <a:t>        printf("fine settimana\n");</a:t>
             </a:r>
-            <a:endParaRPr lang="en-US" sz="1350" dirty="0"/>
+            <a:endParaRPr lang="en-US" sz="1400" dirty="0"/>
           </a:p>
           <a:p>
             <a:pPr algn="l" indent="0" marL="0">
@@ -6142,7 +6100,7 @@
               <a:buNone/>
             </a:pPr>
             <a:r>
-              <a:rPr lang="en-US" sz="1350" dirty="0">
+              <a:rPr lang="en-US" sz="1400" dirty="0">
                 <a:solidFill>
                   <a:srgbClr val="24292E"/>
                 </a:solidFill>
@@ -6152,7 +6110,7 @@
               </a:rPr>
               <a:t>        break;</a:t>
             </a:r>
-            <a:endParaRPr lang="en-US" sz="1350" dirty="0"/>
+            <a:endParaRPr lang="en-US" sz="1400" dirty="0"/>
           </a:p>
           <a:p>
             <a:pPr algn="l" indent="0" marL="0">
@@ -6162,7 +6120,7 @@
               <a:buNone/>
             </a:pPr>
             <a:r>
-              <a:rPr lang="en-US" sz="1350" dirty="0">
+              <a:rPr lang="en-US" sz="1400" dirty="0">
                 <a:solidFill>
                   <a:srgbClr val="24292E"/>
                 </a:solidFill>
@@ -6172,7 +6130,7 @@
               </a:rPr>
               <a:t>    default:</a:t>
             </a:r>
-            <a:endParaRPr lang="en-US" sz="1350" dirty="0"/>
+            <a:endParaRPr lang="en-US" sz="1400" dirty="0"/>
           </a:p>
           <a:p>
             <a:pPr algn="l" indent="0" marL="0">
@@ -6182,7 +6140,7 @@
               <a:buNone/>
             </a:pPr>
             <a:r>
-              <a:rPr lang="en-US" sz="1350" dirty="0">
+              <a:rPr lang="en-US" sz="1400" dirty="0">
                 <a:solidFill>
                   <a:srgbClr val="24292E"/>
                 </a:solidFill>
@@ -6192,7 +6150,7 @@
               </a:rPr>
               <a:t>        printf("valore non valido\n");</a:t>
             </a:r>
-            <a:endParaRPr lang="en-US" sz="1350" dirty="0"/>
+            <a:endParaRPr lang="en-US" sz="1400" dirty="0"/>
           </a:p>
           <a:p>
             <a:pPr algn="l" indent="0" marL="0">
@@ -6202,7 +6160,7 @@
               <a:buNone/>
             </a:pPr>
             <a:r>
-              <a:rPr lang="en-US" sz="1350" dirty="0">
+              <a:rPr lang="en-US" sz="1400" dirty="0">
                 <a:solidFill>
                   <a:srgbClr val="24292E"/>
                 </a:solidFill>
@@ -6212,7 +6170,7 @@
               </a:rPr>
               <a:t>        break;</a:t>
             </a:r>
-            <a:endParaRPr lang="en-US" sz="1350" dirty="0"/>
+            <a:endParaRPr lang="en-US" sz="1400" dirty="0"/>
           </a:p>
           <a:p>
             <a:pPr algn="l" indent="0" marL="0">
@@ -6222,7 +6180,7 @@
               <a:buNone/>
             </a:pPr>
             <a:r>
-              <a:rPr lang="en-US" sz="1350" dirty="0">
+              <a:rPr lang="en-US" sz="1400" dirty="0">
                 <a:solidFill>
                   <a:srgbClr val="24292E"/>
                 </a:solidFill>
@@ -6232,7 +6190,51 @@
               </a:rPr>
               <a:t>}</a:t>
             </a:r>
-            <a:endParaRPr lang="en-US" sz="1350" dirty="0"/>
+            <a:endParaRPr lang="en-US" sz="1400" dirty="0"/>
+          </a:p>
+        </p:txBody>
+      </p:sp>
+      <p:sp>
+        <p:nvSpPr>
+          <p:cNvPr id="5" name="Text 3"/>
+          <p:cNvSpPr/>
+          <p:nvPr/>
+        </p:nvSpPr>
+        <p:spPr>
+          <a:xfrm>
+            <a:off x="6248244" y="2853809"/>
+            <a:ext cx="5537061" cy="497681"/>
+          </a:xfrm>
+          <a:prstGeom prst="rect">
+            <a:avLst/>
+          </a:prstGeom>
+          <a:noFill/>
+          <a:ln/>
+        </p:spPr>
+        <p:txBody>
+          <a:bodyPr wrap="square" lIns="0" tIns="0" rIns="0" bIns="0" rtlCol="0" anchor="t">
+            <a:normAutofit/>
+          </a:bodyPr>
+          <a:lstStyle/>
+          <a:p>
+            <a:pPr algn="l" indent="0" marL="0">
+              <a:lnSpc>
+                <a:spcPct val="117000"/>
+              </a:lnSpc>
+              <a:buNone/>
+            </a:pPr>
+            <a:r>
+              <a:rPr lang="en-US" sz="1400" dirty="0">
+                <a:solidFill>
+                  <a:srgbClr val="3B3535"/>
+                </a:solidFill>
+                <a:latin typeface="Verdana" pitchFamily="34" charset="0"/>
+                <a:ea typeface="Verdana" pitchFamily="34" charset="-122"/>
+                <a:cs typeface="Verdana" pitchFamily="34" charset="-120"/>
+              </a:rPr>
+              <a:t>Senza break l'esecuzione prosegue nel case successivo (fall-through). Si sfrutta per raggruppare i valori:</a:t>
+            </a:r>
+            <a:endParaRPr lang="en-US" sz="1400" dirty="0"/>
           </a:p>
         </p:txBody>
       </p:sp>
@@ -6244,12 +6246,12 @@
         </p:nvSpPr>
         <p:spPr>
           <a:xfrm>
-            <a:off x="406390" y="5967710"/>
-            <a:ext cx="11378915" cy="893961"/>
+            <a:off x="6248244" y="3447058"/>
+            <a:ext cx="5537061" cy="1191022"/>
           </a:xfrm>
           <a:prstGeom prst="roundRect">
             <a:avLst>
-              <a:gd name="adj" fmla="val 1279"/>
+              <a:gd name="adj" fmla="val 960"/>
             </a:avLst>
           </a:prstGeom>
           <a:solidFill>
@@ -6274,8 +6276,8 @@
         </p:blipFill>
         <p:spPr>
           <a:xfrm>
-            <a:off x="576943" y="6209308"/>
-            <a:ext cx="213216" cy="170557"/>
+            <a:off x="6426039" y="3704233"/>
+            <a:ext cx="222244" cy="177800"/>
           </a:xfrm>
           <a:prstGeom prst="rect">
             <a:avLst/>
@@ -6290,8 +6292,8 @@
         </p:nvSpPr>
         <p:spPr>
           <a:xfrm>
-            <a:off x="960711" y="6189016"/>
-            <a:ext cx="10654041" cy="467717"/>
+            <a:off x="6826079" y="3678515"/>
+            <a:ext cx="4781430" cy="746522"/>
           </a:xfrm>
           <a:prstGeom prst="rect">
             <a:avLst/>
@@ -6307,12 +6309,12 @@
           <a:p>
             <a:pPr algn="l" indent="0" marL="0">
               <a:lnSpc>
-                <a:spcPct val="114000"/>
-              </a:lnSpc>
-              <a:buNone/>
-            </a:pPr>
-            <a:r>
-              <a:rPr lang="en-US" sz="1350" dirty="0">
+                <a:spcPct val="117000"/>
+              </a:lnSpc>
+              <a:buNone/>
+            </a:pPr>
+            <a:r>
+              <a:rPr lang="en-US" sz="1400" dirty="0">
                 <a:solidFill>
                   <a:srgbClr val="000000"/>
                 </a:solidFill>
@@ -6322,7 +6324,7 @@
               </a:rPr>
               <a:t>Il break dello switch è l'unico break ammesso dalle convenzioni del corso. Per intervalli e condizioni composte si usa la catena else-if.</a:t>
             </a:r>
-            <a:endParaRPr lang="en-US" sz="1350" dirty="0"/>
+            <a:endParaRPr lang="en-US" sz="1400" dirty="0"/>
           </a:p>
         </p:txBody>
       </p:sp>

</xml_diff>

<commit_message>
Presentazioni 01, 02, 03, 04.01: titoli allineati in alto
Contenuto delle slide allineato in alto (tranne la copertina), così il
titolo è sempre nella stessa posizione.

Co-Authored-By: Claude Opus 5.5 <noreply@anthropic.com>
Claude-Session: https://claude.ai/code/session_01McKApmha1SUQudA1gmsZp2
</commit_message>
<xml_diff>
--- a/00-Documentazione/Linguaggio-C-02-Il-Controllo-del-Flusso.pptx
+++ b/00-Documentazione/Linguaggio-C-02-Il-Controllo-del-Flusso.pptx
@@ -4130,7 +4130,7 @@
         </p:nvSpPr>
         <p:spPr>
           <a:xfrm>
-            <a:off x="406390" y="1343115"/>
+            <a:off x="406390" y="276811"/>
             <a:ext cx="11378915" cy="446980"/>
           </a:xfrm>
           <a:prstGeom prst="rect">
@@ -4172,7 +4172,7 @@
         </p:nvSpPr>
         <p:spPr>
           <a:xfrm>
-            <a:off x="406390" y="2145109"/>
+            <a:off x="406390" y="1078805"/>
             <a:ext cx="5537061" cy="2346821"/>
           </a:xfrm>
           <a:prstGeom prst="roundRect">
@@ -4194,7 +4194,7 @@
         </p:nvSpPr>
         <p:spPr>
           <a:xfrm>
-            <a:off x="619705" y="2323227"/>
+            <a:off x="619705" y="1256923"/>
             <a:ext cx="5110432" cy="1991221"/>
           </a:xfrm>
           <a:prstGeom prst="rect">
@@ -4358,7 +4358,7 @@
         </p:nvSpPr>
         <p:spPr>
           <a:xfrm>
-            <a:off x="6248244" y="2651919"/>
+            <a:off x="6248244" y="1585615"/>
             <a:ext cx="5537061" cy="1333103"/>
           </a:xfrm>
           <a:prstGeom prst="rect">
@@ -4445,7 +4445,7 @@
         </p:nvSpPr>
         <p:spPr>
           <a:xfrm>
-            <a:off x="406390" y="4844355"/>
+            <a:off x="406390" y="3778052"/>
             <a:ext cx="11378915" cy="693341"/>
           </a:xfrm>
           <a:prstGeom prst="roundRect">
@@ -4475,7 +4475,7 @@
         </p:blipFill>
         <p:spPr>
           <a:xfrm>
-            <a:off x="584185" y="5101530"/>
+            <a:off x="584185" y="4035227"/>
             <a:ext cx="222244" cy="177800"/>
           </a:xfrm>
           <a:prstGeom prst="rect">
@@ -4491,7 +4491,7 @@
         </p:nvSpPr>
         <p:spPr>
           <a:xfrm>
-            <a:off x="984225" y="5075813"/>
+            <a:off x="984225" y="4009509"/>
             <a:ext cx="11207470" cy="248841"/>
           </a:xfrm>
           <a:prstGeom prst="rect">
@@ -4631,7 +4631,7 @@
         </p:nvSpPr>
         <p:spPr>
           <a:xfrm>
-            <a:off x="406390" y="1197065"/>
+            <a:off x="406390" y="276811"/>
             <a:ext cx="11378915" cy="446980"/>
           </a:xfrm>
           <a:prstGeom prst="rect">
@@ -4673,7 +4673,7 @@
         </p:nvSpPr>
         <p:spPr>
           <a:xfrm>
-            <a:off x="406390" y="1999059"/>
+            <a:off x="406390" y="1078805"/>
             <a:ext cx="5167977" cy="3484662"/>
           </a:xfrm>
           <a:prstGeom prst="roundRect">
@@ -4695,7 +4695,7 @@
         </p:nvSpPr>
         <p:spPr>
           <a:xfrm>
-            <a:off x="619705" y="2177177"/>
+            <a:off x="619705" y="1256923"/>
             <a:ext cx="4741347" cy="3129062"/>
           </a:xfrm>
           <a:prstGeom prst="rect">
@@ -4946,7 +4946,7 @@
           </p:nvPr>
         </p:nvGraphicFramePr>
         <p:xfrm>
-          <a:off x="5879060" y="2576711"/>
+          <a:off x="5879060" y="1656457"/>
           <a:ext cx="5906245" cy="914400"/>
         </p:xfrm>
         <a:graphic>
@@ -5794,7 +5794,7 @@
         </p:nvSpPr>
         <p:spPr>
           <a:xfrm>
-            <a:off x="406390" y="485865"/>
+            <a:off x="406390" y="276811"/>
             <a:ext cx="11378915" cy="446980"/>
           </a:xfrm>
           <a:prstGeom prst="rect">
@@ -5836,7 +5836,7 @@
         </p:nvSpPr>
         <p:spPr>
           <a:xfrm>
-            <a:off x="406390" y="1287859"/>
+            <a:off x="406390" y="1078805"/>
             <a:ext cx="5537061" cy="4906963"/>
           </a:xfrm>
           <a:prstGeom prst="roundRect">
@@ -5858,7 +5858,7 @@
         </p:nvSpPr>
         <p:spPr>
           <a:xfrm>
-            <a:off x="619705" y="1465977"/>
+            <a:off x="619705" y="1256923"/>
             <a:ext cx="5110432" cy="4551363"/>
           </a:xfrm>
           <a:prstGeom prst="rect">
@@ -6202,7 +6202,7 @@
         </p:nvSpPr>
         <p:spPr>
           <a:xfrm>
-            <a:off x="6248244" y="2853809"/>
+            <a:off x="6248244" y="2644755"/>
             <a:ext cx="5537061" cy="497681"/>
           </a:xfrm>
           <a:prstGeom prst="rect">
@@ -6246,7 +6246,7 @@
         </p:nvSpPr>
         <p:spPr>
           <a:xfrm>
-            <a:off x="6248244" y="3447058"/>
+            <a:off x="6248244" y="3238004"/>
             <a:ext cx="5537061" cy="1191022"/>
           </a:xfrm>
           <a:prstGeom prst="roundRect">
@@ -6276,7 +6276,7 @@
         </p:blipFill>
         <p:spPr>
           <a:xfrm>
-            <a:off x="6426039" y="3704233"/>
+            <a:off x="6426039" y="3495179"/>
             <a:ext cx="222244" cy="177800"/>
           </a:xfrm>
           <a:prstGeom prst="rect">
@@ -6292,7 +6292,7 @@
         </p:nvSpPr>
         <p:spPr>
           <a:xfrm>
-            <a:off x="6826079" y="3678515"/>
+            <a:off x="6826079" y="3469461"/>
             <a:ext cx="4781430" cy="746522"/>
           </a:xfrm>
           <a:prstGeom prst="rect">
@@ -6434,7 +6434,7 @@
         </p:nvSpPr>
         <p:spPr>
           <a:xfrm>
-            <a:off x="406390" y="1028989"/>
+            <a:off x="406390" y="276811"/>
             <a:ext cx="11378915" cy="446980"/>
           </a:xfrm>
           <a:prstGeom prst="rect">
@@ -6476,7 +6476,7 @@
         </p:nvSpPr>
         <p:spPr>
           <a:xfrm>
-            <a:off x="406390" y="1830983"/>
+            <a:off x="406390" y="1078805"/>
             <a:ext cx="5167977" cy="1208980"/>
           </a:xfrm>
           <a:prstGeom prst="roundRect">
@@ -6498,7 +6498,7 @@
         </p:nvSpPr>
         <p:spPr>
           <a:xfrm>
-            <a:off x="619705" y="2009100"/>
+            <a:off x="619705" y="1256923"/>
             <a:ext cx="4741347" cy="853380"/>
           </a:xfrm>
           <a:prstGeom prst="rect">
@@ -6582,7 +6582,7 @@
         </p:nvSpPr>
         <p:spPr>
           <a:xfrm>
-            <a:off x="406390" y="3239988"/>
+            <a:off x="406390" y="2487811"/>
             <a:ext cx="5167977" cy="851297"/>
           </a:xfrm>
           <a:prstGeom prst="rect">
@@ -6649,7 +6649,7 @@
         </p:nvSpPr>
         <p:spPr>
           <a:xfrm>
-            <a:off x="406390" y="4196060"/>
+            <a:off x="406390" y="3443883"/>
             <a:ext cx="5167977" cy="835422"/>
           </a:xfrm>
           <a:prstGeom prst="rect">
@@ -6739,7 +6739,7 @@
         </p:nvSpPr>
         <p:spPr>
           <a:xfrm>
-            <a:off x="5879060" y="1830983"/>
+            <a:off x="5879060" y="1078805"/>
             <a:ext cx="5906245" cy="2062361"/>
           </a:xfrm>
           <a:prstGeom prst="roundRect">
@@ -6761,7 +6761,7 @@
         </p:nvSpPr>
         <p:spPr>
           <a:xfrm>
-            <a:off x="6092375" y="2009100"/>
+            <a:off x="6092375" y="1256923"/>
             <a:ext cx="5479615" cy="1706761"/>
           </a:xfrm>
           <a:prstGeom prst="rect">
@@ -6905,7 +6905,7 @@
         </p:nvSpPr>
         <p:spPr>
           <a:xfrm>
-            <a:off x="406390" y="5158482"/>
+            <a:off x="406390" y="4406305"/>
             <a:ext cx="11378915" cy="693341"/>
           </a:xfrm>
           <a:prstGeom prst="roundRect">
@@ -6935,7 +6935,7 @@
         </p:blipFill>
         <p:spPr>
           <a:xfrm>
-            <a:off x="584185" y="5415657"/>
+            <a:off x="584185" y="4663480"/>
             <a:ext cx="222244" cy="177800"/>
           </a:xfrm>
           <a:prstGeom prst="rect">
@@ -6951,7 +6951,7 @@
         </p:nvSpPr>
         <p:spPr>
           <a:xfrm>
-            <a:off x="984225" y="5389940"/>
+            <a:off x="984225" y="4637762"/>
             <a:ext cx="11207470" cy="248841"/>
           </a:xfrm>
           <a:prstGeom prst="rect">
@@ -7091,7 +7091,7 @@
         </p:nvSpPr>
         <p:spPr>
           <a:xfrm>
-            <a:off x="406390" y="1003787"/>
+            <a:off x="406390" y="276811"/>
             <a:ext cx="11378915" cy="446980"/>
           </a:xfrm>
           <a:prstGeom prst="rect">
@@ -7133,7 +7133,7 @@
         </p:nvSpPr>
         <p:spPr>
           <a:xfrm>
-            <a:off x="406390" y="1627981"/>
+            <a:off x="406390" y="901005"/>
             <a:ext cx="11378915" cy="1493441"/>
           </a:xfrm>
           <a:prstGeom prst="roundRect">
@@ -7155,7 +7155,7 @@
         </p:nvSpPr>
         <p:spPr>
           <a:xfrm>
-            <a:off x="619705" y="1806099"/>
+            <a:off x="619705" y="1079123"/>
             <a:ext cx="10952285" cy="1137841"/>
           </a:xfrm>
           <a:prstGeom prst="rect">
@@ -7266,7 +7266,7 @@
           </p:nvPr>
         </p:nvGraphicFramePr>
         <p:xfrm>
-          <a:off x="406390" y="3448447"/>
+          <a:off x="406390" y="2721471"/>
           <a:ext cx="11378916" cy="914400"/>
         </p:xfrm>
         <a:graphic>
@@ -8067,7 +8067,7 @@
         </p:nvSpPr>
         <p:spPr>
           <a:xfrm>
-            <a:off x="406390" y="5183584"/>
+            <a:off x="406390" y="4456609"/>
             <a:ext cx="11378915" cy="693341"/>
           </a:xfrm>
           <a:prstGeom prst="roundRect">
@@ -8097,7 +8097,7 @@
         </p:blipFill>
         <p:spPr>
           <a:xfrm>
-            <a:off x="584185" y="5440759"/>
+            <a:off x="584185" y="4713784"/>
             <a:ext cx="222244" cy="177800"/>
           </a:xfrm>
           <a:prstGeom prst="rect">
@@ -8113,7 +8113,7 @@
         </p:nvSpPr>
         <p:spPr>
           <a:xfrm>
-            <a:off x="984225" y="5415042"/>
+            <a:off x="984225" y="4688066"/>
             <a:ext cx="11207470" cy="248841"/>
           </a:xfrm>
           <a:prstGeom prst="rect">
@@ -8253,7 +8253,7 @@
         </p:nvSpPr>
         <p:spPr>
           <a:xfrm>
-            <a:off x="406390" y="1366035"/>
+            <a:off x="406390" y="276811"/>
             <a:ext cx="11378915" cy="446980"/>
           </a:xfrm>
           <a:prstGeom prst="rect">
@@ -8295,7 +8295,7 @@
         </p:nvSpPr>
         <p:spPr>
           <a:xfrm>
-            <a:off x="406390" y="1977211"/>
+            <a:off x="406390" y="887988"/>
             <a:ext cx="5537061" cy="497681"/>
           </a:xfrm>
           <a:prstGeom prst="rect">
@@ -8339,7 +8339,7 @@
         </p:nvSpPr>
         <p:spPr>
           <a:xfrm>
-            <a:off x="406390" y="2665710"/>
+            <a:off x="406390" y="1576487"/>
             <a:ext cx="5537061" cy="1777901"/>
           </a:xfrm>
           <a:prstGeom prst="roundRect">
@@ -8361,7 +8361,7 @@
         </p:nvSpPr>
         <p:spPr>
           <a:xfrm>
-            <a:off x="619705" y="2843828"/>
+            <a:off x="619705" y="1754604"/>
             <a:ext cx="5110432" cy="1422301"/>
           </a:xfrm>
           <a:prstGeom prst="rect">
@@ -8485,7 +8485,7 @@
         </p:nvSpPr>
         <p:spPr>
           <a:xfrm>
-            <a:off x="6248244" y="1977211"/>
+            <a:off x="6248244" y="887988"/>
             <a:ext cx="5537061" cy="497681"/>
           </a:xfrm>
           <a:prstGeom prst="rect">
@@ -8529,7 +8529,7 @@
         </p:nvSpPr>
         <p:spPr>
           <a:xfrm>
-            <a:off x="6248244" y="2665710"/>
+            <a:off x="6248244" y="1576487"/>
             <a:ext cx="5537061" cy="1208980"/>
           </a:xfrm>
           <a:prstGeom prst="roundRect">
@@ -8551,7 +8551,7 @@
         </p:nvSpPr>
         <p:spPr>
           <a:xfrm>
-            <a:off x="6461559" y="2843828"/>
+            <a:off x="6461559" y="1754604"/>
             <a:ext cx="5110432" cy="853380"/>
           </a:xfrm>
           <a:prstGeom prst="rect">
@@ -8635,7 +8635,7 @@
         </p:nvSpPr>
         <p:spPr>
           <a:xfrm>
-            <a:off x="406390" y="4821436"/>
+            <a:off x="406390" y="3732213"/>
             <a:ext cx="11378915" cy="693341"/>
           </a:xfrm>
           <a:prstGeom prst="roundRect">
@@ -8665,7 +8665,7 @@
         </p:blipFill>
         <p:spPr>
           <a:xfrm>
-            <a:off x="584185" y="5078611"/>
+            <a:off x="584185" y="3989388"/>
             <a:ext cx="222244" cy="177800"/>
           </a:xfrm>
           <a:prstGeom prst="rect">
@@ -8681,7 +8681,7 @@
         </p:nvSpPr>
         <p:spPr>
           <a:xfrm>
-            <a:off x="984225" y="5052894"/>
+            <a:off x="984225" y="3963670"/>
             <a:ext cx="11207470" cy="248841"/>
           </a:xfrm>
           <a:prstGeom prst="rect">
@@ -8821,7 +8821,7 @@
         </p:nvSpPr>
         <p:spPr>
           <a:xfrm>
-            <a:off x="406390" y="1158767"/>
+            <a:off x="406390" y="251411"/>
             <a:ext cx="11378915" cy="446980"/>
           </a:xfrm>
           <a:prstGeom prst="rect">
@@ -8863,7 +8863,7 @@
         </p:nvSpPr>
         <p:spPr>
           <a:xfrm>
-            <a:off x="406390" y="1782961"/>
+            <a:off x="406390" y="875605"/>
             <a:ext cx="11378915" cy="1208980"/>
           </a:xfrm>
           <a:prstGeom prst="roundRect">
@@ -8885,7 +8885,7 @@
         </p:nvSpPr>
         <p:spPr>
           <a:xfrm>
-            <a:off x="619705" y="1961078"/>
+            <a:off x="619705" y="1053723"/>
             <a:ext cx="10952285" cy="853380"/>
           </a:xfrm>
           <a:prstGeom prst="rect">
@@ -8976,7 +8976,7 @@
           </p:nvPr>
         </p:nvGraphicFramePr>
         <p:xfrm>
-          <a:off x="406390" y="3318966"/>
+          <a:off x="406390" y="2411611"/>
           <a:ext cx="5906146" cy="914400"/>
         </p:xfrm>
         <a:graphic>
@@ -9795,7 +9795,7 @@
           </p:nvPr>
         </p:nvGraphicFramePr>
         <p:xfrm>
-          <a:off x="6617229" y="3318966"/>
+          <a:off x="6617229" y="2411611"/>
           <a:ext cx="5168076" cy="914400"/>
         </p:xfrm>
         <a:graphic>
@@ -10346,7 +10346,7 @@
         </p:nvSpPr>
         <p:spPr>
           <a:xfrm>
-            <a:off x="406390" y="5028704"/>
+            <a:off x="406390" y="4121348"/>
             <a:ext cx="11378915" cy="693341"/>
           </a:xfrm>
           <a:prstGeom prst="roundRect">
@@ -10376,7 +10376,7 @@
         </p:blipFill>
         <p:spPr>
           <a:xfrm>
-            <a:off x="584185" y="5285879"/>
+            <a:off x="584185" y="4378523"/>
             <a:ext cx="222244" cy="177800"/>
           </a:xfrm>
           <a:prstGeom prst="rect">
@@ -10392,7 +10392,7 @@
         </p:nvSpPr>
         <p:spPr>
           <a:xfrm>
-            <a:off x="984225" y="5260161"/>
+            <a:off x="984225" y="4352806"/>
             <a:ext cx="11207470" cy="248841"/>
           </a:xfrm>
           <a:prstGeom prst="rect">
@@ -10532,7 +10532,7 @@
         </p:nvSpPr>
         <p:spPr>
           <a:xfrm>
-            <a:off x="406390" y="1281500"/>
+            <a:off x="406390" y="276811"/>
             <a:ext cx="11378915" cy="446980"/>
           </a:xfrm>
           <a:prstGeom prst="rect">
@@ -10574,7 +10574,7 @@
         </p:nvSpPr>
         <p:spPr>
           <a:xfrm>
-            <a:off x="406390" y="1892677"/>
+            <a:off x="406390" y="887988"/>
             <a:ext cx="11785305" cy="248841"/>
           </a:xfrm>
           <a:prstGeom prst="rect">
@@ -10616,7 +10616,7 @@
         </p:nvSpPr>
         <p:spPr>
           <a:xfrm>
-            <a:off x="406390" y="2491085"/>
+            <a:off x="406390" y="1486396"/>
             <a:ext cx="5906146" cy="2062361"/>
           </a:xfrm>
           <a:prstGeom prst="roundRect">
@@ -10638,7 +10638,7 @@
         </p:nvSpPr>
         <p:spPr>
           <a:xfrm>
-            <a:off x="619705" y="2669203"/>
+            <a:off x="619705" y="1664514"/>
             <a:ext cx="5479516" cy="1706761"/>
           </a:xfrm>
           <a:prstGeom prst="rect">
@@ -10782,7 +10782,7 @@
         </p:nvSpPr>
         <p:spPr>
           <a:xfrm>
-            <a:off x="6617229" y="3104555"/>
+            <a:off x="6617229" y="2099866"/>
             <a:ext cx="5168076" cy="835422"/>
           </a:xfrm>
           <a:prstGeom prst="rect">
@@ -10869,7 +10869,7 @@
         </p:nvSpPr>
         <p:spPr>
           <a:xfrm>
-            <a:off x="406390" y="4905871"/>
+            <a:off x="406390" y="3901182"/>
             <a:ext cx="11378915" cy="693341"/>
           </a:xfrm>
           <a:prstGeom prst="roundRect">
@@ -10899,7 +10899,7 @@
         </p:blipFill>
         <p:spPr>
           <a:xfrm>
-            <a:off x="584185" y="5163046"/>
+            <a:off x="584185" y="4158357"/>
             <a:ext cx="222244" cy="177800"/>
           </a:xfrm>
           <a:prstGeom prst="rect">
@@ -10915,7 +10915,7 @@
         </p:nvSpPr>
         <p:spPr>
           <a:xfrm>
-            <a:off x="984225" y="5137329"/>
+            <a:off x="984225" y="4132640"/>
             <a:ext cx="11207470" cy="248841"/>
           </a:xfrm>
           <a:prstGeom prst="rect">
@@ -11055,7 +11055,7 @@
         </p:nvSpPr>
         <p:spPr>
           <a:xfrm>
-            <a:off x="406390" y="1304817"/>
+            <a:off x="406390" y="276811"/>
             <a:ext cx="11378915" cy="446980"/>
           </a:xfrm>
           <a:prstGeom prst="rect">
@@ -11104,7 +11104,7 @@
           </p:nvPr>
         </p:nvGraphicFramePr>
         <p:xfrm>
-          <a:off x="406390" y="1906786"/>
+          <a:off x="406390" y="878780"/>
           <a:ext cx="11378916" cy="914400"/>
         </p:xfrm>
         <a:graphic>
@@ -11523,7 +11523,7 @@
         </p:nvSpPr>
         <p:spPr>
           <a:xfrm>
-            <a:off x="406390" y="3228459"/>
+            <a:off x="406390" y="2200454"/>
             <a:ext cx="11785305" cy="248841"/>
           </a:xfrm>
           <a:prstGeom prst="rect">
@@ -11565,7 +11565,7 @@
         </p:nvSpPr>
         <p:spPr>
           <a:xfrm>
-            <a:off x="406390" y="3626842"/>
+            <a:off x="406390" y="2598837"/>
             <a:ext cx="11378915" cy="1128713"/>
           </a:xfrm>
           <a:prstGeom prst="rect">
@@ -11673,7 +11673,7 @@
         </p:nvSpPr>
         <p:spPr>
           <a:xfrm>
-            <a:off x="406390" y="4882555"/>
+            <a:off x="406390" y="3854549"/>
             <a:ext cx="11378915" cy="693341"/>
           </a:xfrm>
           <a:prstGeom prst="roundRect">
@@ -11703,7 +11703,7 @@
         </p:blipFill>
         <p:spPr>
           <a:xfrm>
-            <a:off x="584185" y="5139730"/>
+            <a:off x="584185" y="4111724"/>
             <a:ext cx="222244" cy="177800"/>
           </a:xfrm>
           <a:prstGeom prst="rect">
@@ -11719,7 +11719,7 @@
         </p:nvSpPr>
         <p:spPr>
           <a:xfrm>
-            <a:off x="984225" y="5114012"/>
+            <a:off x="984225" y="4086007"/>
             <a:ext cx="11207470" cy="248841"/>
           </a:xfrm>
           <a:prstGeom prst="rect">
@@ -11859,7 +11859,7 @@
         </p:nvSpPr>
         <p:spPr>
           <a:xfrm>
-            <a:off x="406390" y="1205995"/>
+            <a:off x="406390" y="276811"/>
             <a:ext cx="11378915" cy="446980"/>
           </a:xfrm>
           <a:prstGeom prst="rect">
@@ -11901,7 +11901,7 @@
         </p:nvSpPr>
         <p:spPr>
           <a:xfrm>
-            <a:off x="406390" y="1817172"/>
+            <a:off x="406390" y="887988"/>
             <a:ext cx="5537061" cy="248841"/>
           </a:xfrm>
           <a:prstGeom prst="rect">
@@ -11943,7 +11943,7 @@
         </p:nvSpPr>
         <p:spPr>
           <a:xfrm>
-            <a:off x="406390" y="2256830"/>
+            <a:off x="406390" y="1327646"/>
             <a:ext cx="5537061" cy="2346821"/>
           </a:xfrm>
           <a:prstGeom prst="roundRect">
@@ -11965,7 +11965,7 @@
         </p:nvSpPr>
         <p:spPr>
           <a:xfrm>
-            <a:off x="619705" y="2434947"/>
+            <a:off x="619705" y="1505764"/>
             <a:ext cx="5110432" cy="1991221"/>
           </a:xfrm>
           <a:prstGeom prst="rect">
@@ -12129,7 +12129,7 @@
         </p:nvSpPr>
         <p:spPr>
           <a:xfrm>
-            <a:off x="6248244" y="1817172"/>
+            <a:off x="6248244" y="887988"/>
             <a:ext cx="5537061" cy="248841"/>
           </a:xfrm>
           <a:prstGeom prst="rect">
@@ -12171,7 +12171,7 @@
         </p:nvSpPr>
         <p:spPr>
           <a:xfrm>
-            <a:off x="6248244" y="2256830"/>
+            <a:off x="6248244" y="1327646"/>
             <a:ext cx="5537061" cy="1777901"/>
           </a:xfrm>
           <a:prstGeom prst="roundRect">
@@ -12193,7 +12193,7 @@
         </p:nvSpPr>
         <p:spPr>
           <a:xfrm>
-            <a:off x="6461559" y="2434947"/>
+            <a:off x="6461559" y="1505764"/>
             <a:ext cx="5110432" cy="1422301"/>
           </a:xfrm>
           <a:prstGeom prst="rect">
@@ -12317,7 +12317,7 @@
         </p:nvSpPr>
         <p:spPr>
           <a:xfrm>
-            <a:off x="406390" y="4981476"/>
+            <a:off x="406390" y="4052292"/>
             <a:ext cx="11378915" cy="693341"/>
           </a:xfrm>
           <a:prstGeom prst="roundRect">
@@ -12347,7 +12347,7 @@
         </p:blipFill>
         <p:spPr>
           <a:xfrm>
-            <a:off x="584185" y="5238651"/>
+            <a:off x="584185" y="4309467"/>
             <a:ext cx="222244" cy="177800"/>
           </a:xfrm>
           <a:prstGeom prst="rect">
@@ -12363,7 +12363,7 @@
         </p:nvSpPr>
         <p:spPr>
           <a:xfrm>
-            <a:off x="984225" y="5212933"/>
+            <a:off x="984225" y="4283750"/>
             <a:ext cx="11207470" cy="248841"/>
           </a:xfrm>
           <a:prstGeom prst="rect">
@@ -12503,7 +12503,7 @@
         </p:nvSpPr>
         <p:spPr>
           <a:xfrm>
-            <a:off x="406390" y="1587392"/>
+            <a:off x="406390" y="276811"/>
             <a:ext cx="11378915" cy="446980"/>
           </a:xfrm>
           <a:prstGeom prst="rect">
@@ -12545,7 +12545,7 @@
         </p:nvSpPr>
         <p:spPr>
           <a:xfrm>
-            <a:off x="406390" y="2198569"/>
+            <a:off x="406390" y="887988"/>
             <a:ext cx="11785305" cy="248841"/>
           </a:xfrm>
           <a:prstGeom prst="rect">
@@ -12594,7 +12594,7 @@
           </p:nvPr>
         </p:nvGraphicFramePr>
         <p:xfrm>
-          <a:off x="406390" y="2590602"/>
+          <a:off x="406390" y="1280021"/>
           <a:ext cx="11378916" cy="914400"/>
         </p:xfrm>
         <a:graphic>
@@ -13518,7 +13518,7 @@
         </p:nvSpPr>
         <p:spPr>
           <a:xfrm>
-            <a:off x="406390" y="4351139"/>
+            <a:off x="406390" y="3040559"/>
             <a:ext cx="11378915" cy="942181"/>
           </a:xfrm>
           <a:prstGeom prst="roundRect">
@@ -13548,7 +13548,7 @@
         </p:blipFill>
         <p:spPr>
           <a:xfrm>
-            <a:off x="584185" y="4608314"/>
+            <a:off x="584185" y="3297734"/>
             <a:ext cx="222244" cy="177800"/>
           </a:xfrm>
           <a:prstGeom prst="rect">
@@ -13564,7 +13564,7 @@
         </p:nvSpPr>
         <p:spPr>
           <a:xfrm>
-            <a:off x="984225" y="4582597"/>
+            <a:off x="984225" y="3272016"/>
             <a:ext cx="10623284" cy="497681"/>
           </a:xfrm>
           <a:prstGeom prst="rect">
@@ -13706,7 +13706,7 @@
         </p:nvSpPr>
         <p:spPr>
           <a:xfrm>
-            <a:off x="406390" y="1983969"/>
+            <a:off x="406390" y="276811"/>
             <a:ext cx="11378915" cy="446980"/>
           </a:xfrm>
           <a:prstGeom prst="rect">
@@ -13748,7 +13748,7 @@
         </p:nvSpPr>
         <p:spPr>
           <a:xfrm>
-            <a:off x="406390" y="2585938"/>
+            <a:off x="406390" y="878780"/>
             <a:ext cx="5613260" cy="751681"/>
           </a:xfrm>
           <a:prstGeom prst="roundRect">
@@ -13770,7 +13770,7 @@
         </p:nvSpPr>
         <p:spPr>
           <a:xfrm>
-            <a:off x="558786" y="2722146"/>
+            <a:off x="558786" y="1014988"/>
             <a:ext cx="5308467" cy="497681"/>
           </a:xfrm>
           <a:prstGeom prst="rect">
@@ -13814,7 +13814,7 @@
         </p:nvSpPr>
         <p:spPr>
           <a:xfrm>
-            <a:off x="6172046" y="2585938"/>
+            <a:off x="6172046" y="878780"/>
             <a:ext cx="5613260" cy="751681"/>
           </a:xfrm>
           <a:prstGeom prst="roundRect">
@@ -13836,7 +13836,7 @@
         </p:nvSpPr>
         <p:spPr>
           <a:xfrm>
-            <a:off x="6324442" y="2722146"/>
+            <a:off x="6324442" y="1014988"/>
             <a:ext cx="5308467" cy="497681"/>
           </a:xfrm>
           <a:prstGeom prst="rect">
@@ -13880,7 +13880,7 @@
         </p:nvSpPr>
         <p:spPr>
           <a:xfrm>
-            <a:off x="406390" y="3489920"/>
+            <a:off x="406390" y="1782763"/>
             <a:ext cx="5613260" cy="751681"/>
           </a:xfrm>
           <a:prstGeom prst="roundRect">
@@ -13902,7 +13902,7 @@
         </p:nvSpPr>
         <p:spPr>
           <a:xfrm>
-            <a:off x="558786" y="3626128"/>
+            <a:off x="558786" y="1918970"/>
             <a:ext cx="5308467" cy="497681"/>
           </a:xfrm>
           <a:prstGeom prst="rect">
@@ -13946,7 +13946,7 @@
         </p:nvSpPr>
         <p:spPr>
           <a:xfrm>
-            <a:off x="6172046" y="3489920"/>
+            <a:off x="6172046" y="1782763"/>
             <a:ext cx="5613260" cy="751681"/>
           </a:xfrm>
           <a:prstGeom prst="roundRect">
@@ -13968,7 +13968,7 @@
         </p:nvSpPr>
         <p:spPr>
           <a:xfrm>
-            <a:off x="6324442" y="3626128"/>
+            <a:off x="6324442" y="1918970"/>
             <a:ext cx="5308467" cy="497681"/>
           </a:xfrm>
           <a:prstGeom prst="rect">
@@ -14012,7 +14012,7 @@
         </p:nvSpPr>
         <p:spPr>
           <a:xfrm>
-            <a:off x="406390" y="4393902"/>
+            <a:off x="406390" y="2686745"/>
             <a:ext cx="5613260" cy="502841"/>
           </a:xfrm>
           <a:prstGeom prst="roundRect">
@@ -14034,7 +14034,7 @@
         </p:nvSpPr>
         <p:spPr>
           <a:xfrm>
-            <a:off x="558786" y="4530110"/>
+            <a:off x="558786" y="2822952"/>
             <a:ext cx="5460863" cy="248841"/>
           </a:xfrm>
           <a:prstGeom prst="rect">
@@ -14076,7 +14076,7 @@
         </p:nvSpPr>
         <p:spPr>
           <a:xfrm>
-            <a:off x="6172046" y="4393902"/>
+            <a:off x="6172046" y="2686745"/>
             <a:ext cx="5613260" cy="502841"/>
           </a:xfrm>
           <a:prstGeom prst="roundRect">
@@ -14098,7 +14098,7 @@
         </p:nvSpPr>
         <p:spPr>
           <a:xfrm>
-            <a:off x="6324442" y="4530110"/>
+            <a:off x="6324442" y="2822952"/>
             <a:ext cx="5460863" cy="248841"/>
           </a:xfrm>
           <a:prstGeom prst="rect">
@@ -14238,7 +14238,7 @@
         </p:nvSpPr>
         <p:spPr>
           <a:xfrm>
-            <a:off x="406390" y="957551"/>
+            <a:off x="406390" y="226011"/>
             <a:ext cx="11378915" cy="446980"/>
           </a:xfrm>
           <a:prstGeom prst="rect">
@@ -14287,7 +14287,7 @@
           </p:nvPr>
         </p:nvGraphicFramePr>
         <p:xfrm>
-          <a:off x="406390" y="1559520"/>
+          <a:off x="406390" y="827980"/>
           <a:ext cx="11378916" cy="914400"/>
         </p:xfrm>
         <a:graphic>
@@ -16576,7 +16576,7 @@
         </p:nvSpPr>
         <p:spPr>
           <a:xfrm>
-            <a:off x="406390" y="1577439"/>
+            <a:off x="406390" y="234315"/>
             <a:ext cx="11785305" cy="186630"/>
           </a:xfrm>
           <a:prstGeom prst="rect">
@@ -16618,7 +16618,7 @@
         </p:nvSpPr>
         <p:spPr>
           <a:xfrm>
-            <a:off x="406390" y="1854191"/>
+            <a:off x="406390" y="511067"/>
             <a:ext cx="11378915" cy="446980"/>
           </a:xfrm>
           <a:prstGeom prst="rect">
@@ -16660,7 +16660,7 @@
         </p:nvSpPr>
         <p:spPr>
           <a:xfrm>
-            <a:off x="406390" y="2465368"/>
+            <a:off x="406390" y="1122244"/>
             <a:ext cx="11785305" cy="248841"/>
           </a:xfrm>
           <a:prstGeom prst="rect">
@@ -16702,7 +16702,7 @@
         </p:nvSpPr>
         <p:spPr>
           <a:xfrm>
-            <a:off x="406390" y="2832001"/>
+            <a:off x="406390" y="1488877"/>
             <a:ext cx="2730432" cy="2454275"/>
           </a:xfrm>
           <a:prstGeom prst="roundRect">
@@ -16724,7 +16724,7 @@
         </p:nvSpPr>
         <p:spPr>
           <a:xfrm>
-            <a:off x="533387" y="2959001"/>
+            <a:off x="533387" y="1615877"/>
             <a:ext cx="2476438" cy="1951434"/>
           </a:xfrm>
           <a:prstGeom prst="rect">
@@ -16812,7 +16812,7 @@
         </p:nvSpPr>
         <p:spPr>
           <a:xfrm>
-            <a:off x="3289218" y="2832001"/>
+            <a:off x="3289218" y="1488877"/>
             <a:ext cx="2730432" cy="2454275"/>
           </a:xfrm>
           <a:prstGeom prst="roundRect">
@@ -16834,7 +16834,7 @@
         </p:nvSpPr>
         <p:spPr>
           <a:xfrm>
-            <a:off x="3416215" y="2959001"/>
+            <a:off x="3416215" y="1615877"/>
             <a:ext cx="2476438" cy="2200275"/>
           </a:xfrm>
           <a:prstGeom prst="rect">
@@ -16922,7 +16922,7 @@
         </p:nvSpPr>
         <p:spPr>
           <a:xfrm>
-            <a:off x="6172046" y="2832001"/>
+            <a:off x="6172046" y="1488877"/>
             <a:ext cx="2730432" cy="2454275"/>
           </a:xfrm>
           <a:prstGeom prst="roundRect">
@@ -16944,7 +16944,7 @@
         </p:nvSpPr>
         <p:spPr>
           <a:xfrm>
-            <a:off x="6299042" y="2959001"/>
+            <a:off x="6299042" y="1615877"/>
             <a:ext cx="2476438" cy="1951434"/>
           </a:xfrm>
           <a:prstGeom prst="rect">
@@ -17034,7 +17034,7 @@
         </p:nvSpPr>
         <p:spPr>
           <a:xfrm>
-            <a:off x="9054873" y="2832001"/>
+            <a:off x="9054873" y="1488877"/>
             <a:ext cx="2730432" cy="2454275"/>
           </a:xfrm>
           <a:prstGeom prst="roundRect">
@@ -17056,7 +17056,7 @@
         </p:nvSpPr>
         <p:spPr>
           <a:xfrm>
-            <a:off x="9181870" y="2959001"/>
+            <a:off x="9181870" y="1615877"/>
             <a:ext cx="2476438" cy="1951434"/>
           </a:xfrm>
           <a:prstGeom prst="rect">
@@ -17244,7 +17244,7 @@
         </p:nvSpPr>
         <p:spPr>
           <a:xfrm>
-            <a:off x="406390" y="1709400"/>
+            <a:off x="406390" y="259715"/>
             <a:ext cx="11785305" cy="186630"/>
           </a:xfrm>
           <a:prstGeom prst="rect">
@@ -17286,7 +17286,7 @@
         </p:nvSpPr>
         <p:spPr>
           <a:xfrm>
-            <a:off x="406390" y="1986152"/>
+            <a:off x="406390" y="536467"/>
             <a:ext cx="11378915" cy="446980"/>
           </a:xfrm>
           <a:prstGeom prst="rect">
@@ -17328,7 +17328,7 @@
         </p:nvSpPr>
         <p:spPr>
           <a:xfrm>
-            <a:off x="406390" y="2588121"/>
+            <a:off x="406390" y="1138436"/>
             <a:ext cx="5537061" cy="1455738"/>
           </a:xfrm>
           <a:prstGeom prst="roundRect">
@@ -17350,7 +17350,7 @@
         </p:nvSpPr>
         <p:spPr>
           <a:xfrm>
-            <a:off x="584185" y="2765921"/>
+            <a:off x="584185" y="1316236"/>
             <a:ext cx="5181470" cy="851297"/>
           </a:xfrm>
           <a:prstGeom prst="rect">
@@ -17415,7 +17415,7 @@
         </p:nvSpPr>
         <p:spPr>
           <a:xfrm>
-            <a:off x="6248244" y="2588121"/>
+            <a:off x="6248244" y="1138436"/>
             <a:ext cx="5537061" cy="1455738"/>
           </a:xfrm>
           <a:prstGeom prst="roundRect">
@@ -17437,7 +17437,7 @@
         </p:nvSpPr>
         <p:spPr>
           <a:xfrm>
-            <a:off x="6426039" y="2765921"/>
+            <a:off x="6426039" y="1316236"/>
             <a:ext cx="5181470" cy="1100138"/>
           </a:xfrm>
           <a:prstGeom prst="rect">
@@ -17502,7 +17502,7 @@
         </p:nvSpPr>
         <p:spPr>
           <a:xfrm>
-            <a:off x="406390" y="4196259"/>
+            <a:off x="406390" y="2746573"/>
             <a:ext cx="11378915" cy="958056"/>
           </a:xfrm>
           <a:prstGeom prst="roundRect">
@@ -17524,7 +17524,7 @@
         </p:nvSpPr>
         <p:spPr>
           <a:xfrm>
-            <a:off x="584185" y="4374059"/>
+            <a:off x="584185" y="2924373"/>
             <a:ext cx="11023324" cy="602456"/>
           </a:xfrm>
           <a:prstGeom prst="rect">
@@ -17687,7 +17687,7 @@
         </p:nvSpPr>
         <p:spPr>
           <a:xfrm>
-            <a:off x="406390" y="1762780"/>
+            <a:off x="406390" y="259715"/>
             <a:ext cx="11785305" cy="186630"/>
           </a:xfrm>
           <a:prstGeom prst="rect">
@@ -17729,7 +17729,7 @@
         </p:nvSpPr>
         <p:spPr>
           <a:xfrm>
-            <a:off x="406390" y="2039532"/>
+            <a:off x="406390" y="536467"/>
             <a:ext cx="11378915" cy="446980"/>
           </a:xfrm>
           <a:prstGeom prst="rect">
@@ -17771,7 +17771,7 @@
         </p:nvSpPr>
         <p:spPr>
           <a:xfrm>
-            <a:off x="406390" y="2650708"/>
+            <a:off x="406390" y="1147644"/>
             <a:ext cx="11785305" cy="248841"/>
           </a:xfrm>
           <a:prstGeom prst="rect">
@@ -17813,7 +17813,7 @@
         </p:nvSpPr>
         <p:spPr>
           <a:xfrm>
-            <a:off x="406390" y="3042741"/>
+            <a:off x="406390" y="1539677"/>
             <a:ext cx="3589744" cy="2058194"/>
           </a:xfrm>
           <a:prstGeom prst="roundRect">
@@ -17835,7 +17835,7 @@
         </p:nvSpPr>
         <p:spPr>
           <a:xfrm>
-            <a:off x="584185" y="3220541"/>
+            <a:off x="584185" y="1717477"/>
             <a:ext cx="3234153" cy="1702594"/>
           </a:xfrm>
           <a:prstGeom prst="rect">
@@ -17923,7 +17923,7 @@
         </p:nvSpPr>
         <p:spPr>
           <a:xfrm>
-            <a:off x="4300926" y="3042741"/>
+            <a:off x="4300926" y="1539677"/>
             <a:ext cx="3589744" cy="2058194"/>
           </a:xfrm>
           <a:prstGeom prst="roundRect">
@@ -17945,7 +17945,7 @@
         </p:nvSpPr>
         <p:spPr>
           <a:xfrm>
-            <a:off x="4478722" y="3220541"/>
+            <a:off x="4478722" y="1717477"/>
             <a:ext cx="3234153" cy="1702594"/>
           </a:xfrm>
           <a:prstGeom prst="rect">
@@ -18033,7 +18033,7 @@
         </p:nvSpPr>
         <p:spPr>
           <a:xfrm>
-            <a:off x="8195462" y="3042741"/>
+            <a:off x="8195462" y="1539677"/>
             <a:ext cx="3589744" cy="2058194"/>
           </a:xfrm>
           <a:prstGeom prst="roundRect">
@@ -18055,7 +18055,7 @@
         </p:nvSpPr>
         <p:spPr>
           <a:xfrm>
-            <a:off x="8373258" y="3220541"/>
+            <a:off x="8373258" y="1717477"/>
             <a:ext cx="3234153" cy="1204913"/>
           </a:xfrm>
           <a:prstGeom prst="rect">
@@ -18241,7 +18241,7 @@
         </p:nvSpPr>
         <p:spPr>
           <a:xfrm>
-            <a:off x="406390" y="1833820"/>
+            <a:off x="406390" y="259715"/>
             <a:ext cx="11785305" cy="186630"/>
           </a:xfrm>
           <a:prstGeom prst="rect">
@@ -18283,7 +18283,7 @@
         </p:nvSpPr>
         <p:spPr>
           <a:xfrm>
-            <a:off x="406390" y="2110572"/>
+            <a:off x="406390" y="536467"/>
             <a:ext cx="11378915" cy="446980"/>
           </a:xfrm>
           <a:prstGeom prst="rect">
@@ -18325,7 +18325,7 @@
         </p:nvSpPr>
         <p:spPr>
           <a:xfrm>
-            <a:off x="406390" y="2712541"/>
+            <a:off x="406390" y="1138436"/>
             <a:ext cx="5537061" cy="1206897"/>
           </a:xfrm>
           <a:prstGeom prst="roundRect">
@@ -18347,7 +18347,7 @@
         </p:nvSpPr>
         <p:spPr>
           <a:xfrm>
-            <a:off x="584185" y="2890341"/>
+            <a:off x="584185" y="1316236"/>
             <a:ext cx="5181470" cy="851297"/>
           </a:xfrm>
           <a:prstGeom prst="rect">
@@ -18412,7 +18412,7 @@
         </p:nvSpPr>
         <p:spPr>
           <a:xfrm>
-            <a:off x="6248244" y="2712541"/>
+            <a:off x="6248244" y="1138436"/>
             <a:ext cx="5537061" cy="1206897"/>
           </a:xfrm>
           <a:prstGeom prst="roundRect">
@@ -18434,7 +18434,7 @@
         </p:nvSpPr>
         <p:spPr>
           <a:xfrm>
-            <a:off x="6426039" y="2890341"/>
+            <a:off x="6426039" y="1316236"/>
             <a:ext cx="5181470" cy="851297"/>
           </a:xfrm>
           <a:prstGeom prst="rect">
@@ -18499,7 +18499,7 @@
         </p:nvSpPr>
         <p:spPr>
           <a:xfrm>
-            <a:off x="406390" y="4071838"/>
+            <a:off x="406390" y="2497733"/>
             <a:ext cx="11378915" cy="958056"/>
           </a:xfrm>
           <a:prstGeom prst="roundRect">
@@ -18521,7 +18521,7 @@
         </p:nvSpPr>
         <p:spPr>
           <a:xfrm>
-            <a:off x="584185" y="4249638"/>
+            <a:off x="584185" y="2675533"/>
             <a:ext cx="11023324" cy="602456"/>
           </a:xfrm>
           <a:prstGeom prst="rect">
@@ -18684,7 +18684,7 @@
         </p:nvSpPr>
         <p:spPr>
           <a:xfrm>
-            <a:off x="406390" y="1762780"/>
+            <a:off x="406390" y="259715"/>
             <a:ext cx="11785305" cy="186630"/>
           </a:xfrm>
           <a:prstGeom prst="rect">
@@ -18726,7 +18726,7 @@
         </p:nvSpPr>
         <p:spPr>
           <a:xfrm>
-            <a:off x="406390" y="2039532"/>
+            <a:off x="406390" y="536467"/>
             <a:ext cx="11378915" cy="446980"/>
           </a:xfrm>
           <a:prstGeom prst="rect">
@@ -18768,7 +18768,7 @@
         </p:nvSpPr>
         <p:spPr>
           <a:xfrm>
-            <a:off x="406390" y="2650708"/>
+            <a:off x="406390" y="1147644"/>
             <a:ext cx="11785305" cy="248841"/>
           </a:xfrm>
           <a:prstGeom prst="rect">
@@ -18810,7 +18810,7 @@
         </p:nvSpPr>
         <p:spPr>
           <a:xfrm>
-            <a:off x="406390" y="3042741"/>
+            <a:off x="406390" y="1539677"/>
             <a:ext cx="3589744" cy="2058194"/>
           </a:xfrm>
           <a:prstGeom prst="roundRect">
@@ -18832,7 +18832,7 @@
         </p:nvSpPr>
         <p:spPr>
           <a:xfrm>
-            <a:off x="584185" y="3220541"/>
+            <a:off x="584185" y="1717477"/>
             <a:ext cx="3234153" cy="1702594"/>
           </a:xfrm>
           <a:prstGeom prst="rect">
@@ -18920,7 +18920,7 @@
         </p:nvSpPr>
         <p:spPr>
           <a:xfrm>
-            <a:off x="4300926" y="3042741"/>
+            <a:off x="4300926" y="1539677"/>
             <a:ext cx="3589744" cy="2058194"/>
           </a:xfrm>
           <a:prstGeom prst="roundRect">
@@ -18942,7 +18942,7 @@
         </p:nvSpPr>
         <p:spPr>
           <a:xfrm>
-            <a:off x="4478722" y="3220541"/>
+            <a:off x="4478722" y="1717477"/>
             <a:ext cx="3234153" cy="1702594"/>
           </a:xfrm>
           <a:prstGeom prst="rect">
@@ -19030,7 +19030,7 @@
         </p:nvSpPr>
         <p:spPr>
           <a:xfrm>
-            <a:off x="8195462" y="3042741"/>
+            <a:off x="8195462" y="1539677"/>
             <a:ext cx="3589744" cy="2058194"/>
           </a:xfrm>
           <a:prstGeom prst="roundRect">
@@ -19052,7 +19052,7 @@
         </p:nvSpPr>
         <p:spPr>
           <a:xfrm>
-            <a:off x="8373258" y="3220541"/>
+            <a:off x="8373258" y="1717477"/>
             <a:ext cx="3234153" cy="1453753"/>
           </a:xfrm>
           <a:prstGeom prst="rect">
@@ -19238,7 +19238,7 @@
         </p:nvSpPr>
         <p:spPr>
           <a:xfrm>
-            <a:off x="406390" y="1833820"/>
+            <a:off x="406390" y="259715"/>
             <a:ext cx="11785305" cy="186630"/>
           </a:xfrm>
           <a:prstGeom prst="rect">
@@ -19280,7 +19280,7 @@
         </p:nvSpPr>
         <p:spPr>
           <a:xfrm>
-            <a:off x="406390" y="2110572"/>
+            <a:off x="406390" y="536467"/>
             <a:ext cx="11378915" cy="446980"/>
           </a:xfrm>
           <a:prstGeom prst="rect">
@@ -19322,7 +19322,7 @@
         </p:nvSpPr>
         <p:spPr>
           <a:xfrm>
-            <a:off x="406390" y="2712541"/>
+            <a:off x="406390" y="1138436"/>
             <a:ext cx="5537061" cy="1206897"/>
           </a:xfrm>
           <a:prstGeom prst="roundRect">
@@ -19344,7 +19344,7 @@
         </p:nvSpPr>
         <p:spPr>
           <a:xfrm>
-            <a:off x="584185" y="2890341"/>
+            <a:off x="584185" y="1316236"/>
             <a:ext cx="5181470" cy="851297"/>
           </a:xfrm>
           <a:prstGeom prst="rect">
@@ -19409,7 +19409,7 @@
         </p:nvSpPr>
         <p:spPr>
           <a:xfrm>
-            <a:off x="6248244" y="2712541"/>
+            <a:off x="6248244" y="1138436"/>
             <a:ext cx="5537061" cy="1206897"/>
           </a:xfrm>
           <a:prstGeom prst="roundRect">
@@ -19431,7 +19431,7 @@
         </p:nvSpPr>
         <p:spPr>
           <a:xfrm>
-            <a:off x="6426039" y="2890341"/>
+            <a:off x="6426039" y="1316236"/>
             <a:ext cx="5181470" cy="851297"/>
           </a:xfrm>
           <a:prstGeom prst="rect">
@@ -19496,7 +19496,7 @@
         </p:nvSpPr>
         <p:spPr>
           <a:xfrm>
-            <a:off x="406390" y="4071838"/>
+            <a:off x="406390" y="2497733"/>
             <a:ext cx="11378915" cy="958056"/>
           </a:xfrm>
           <a:prstGeom prst="roundRect">
@@ -19518,7 +19518,7 @@
         </p:nvSpPr>
         <p:spPr>
           <a:xfrm>
-            <a:off x="584185" y="4249638"/>
+            <a:off x="584185" y="2675533"/>
             <a:ext cx="11023324" cy="602456"/>
           </a:xfrm>
           <a:prstGeom prst="rect">
@@ -19681,7 +19681,7 @@
         </p:nvSpPr>
         <p:spPr>
           <a:xfrm>
-            <a:off x="406390" y="1762780"/>
+            <a:off x="406390" y="259715"/>
             <a:ext cx="11785305" cy="186630"/>
           </a:xfrm>
           <a:prstGeom prst="rect">
@@ -19723,7 +19723,7 @@
         </p:nvSpPr>
         <p:spPr>
           <a:xfrm>
-            <a:off x="406390" y="2039532"/>
+            <a:off x="406390" y="536467"/>
             <a:ext cx="11378915" cy="446980"/>
           </a:xfrm>
           <a:prstGeom prst="rect">
@@ -19765,7 +19765,7 @@
         </p:nvSpPr>
         <p:spPr>
           <a:xfrm>
-            <a:off x="406390" y="2650708"/>
+            <a:off x="406390" y="1147644"/>
             <a:ext cx="11785305" cy="248841"/>
           </a:xfrm>
           <a:prstGeom prst="rect">
@@ -19807,7 +19807,7 @@
         </p:nvSpPr>
         <p:spPr>
           <a:xfrm>
-            <a:off x="406390" y="3042741"/>
+            <a:off x="406390" y="1539677"/>
             <a:ext cx="3589744" cy="2058194"/>
           </a:xfrm>
           <a:prstGeom prst="roundRect">
@@ -19829,7 +19829,7 @@
         </p:nvSpPr>
         <p:spPr>
           <a:xfrm>
-            <a:off x="584185" y="3220541"/>
+            <a:off x="584185" y="1717477"/>
             <a:ext cx="3234153" cy="1702594"/>
           </a:xfrm>
           <a:prstGeom prst="rect">
@@ -19917,7 +19917,7 @@
         </p:nvSpPr>
         <p:spPr>
           <a:xfrm>
-            <a:off x="4300926" y="3042741"/>
+            <a:off x="4300926" y="1539677"/>
             <a:ext cx="3589744" cy="2058194"/>
           </a:xfrm>
           <a:prstGeom prst="roundRect">
@@ -19939,7 +19939,7 @@
         </p:nvSpPr>
         <p:spPr>
           <a:xfrm>
-            <a:off x="4478722" y="3220541"/>
+            <a:off x="4478722" y="1717477"/>
             <a:ext cx="3234153" cy="1702594"/>
           </a:xfrm>
           <a:prstGeom prst="rect">
@@ -20027,7 +20027,7 @@
         </p:nvSpPr>
         <p:spPr>
           <a:xfrm>
-            <a:off x="8195462" y="3042741"/>
+            <a:off x="8195462" y="1539677"/>
             <a:ext cx="3589744" cy="2058194"/>
           </a:xfrm>
           <a:prstGeom prst="roundRect">
@@ -20049,7 +20049,7 @@
         </p:nvSpPr>
         <p:spPr>
           <a:xfrm>
-            <a:off x="8373258" y="3220541"/>
+            <a:off x="8373258" y="1717477"/>
             <a:ext cx="3234153" cy="1702594"/>
           </a:xfrm>
           <a:prstGeom prst="rect">
@@ -20235,7 +20235,7 @@
         </p:nvSpPr>
         <p:spPr>
           <a:xfrm>
-            <a:off x="406390" y="1897320"/>
+            <a:off x="406390" y="234315"/>
             <a:ext cx="11785305" cy="186630"/>
           </a:xfrm>
           <a:prstGeom prst="rect">
@@ -20277,7 +20277,7 @@
         </p:nvSpPr>
         <p:spPr>
           <a:xfrm>
-            <a:off x="406390" y="2174072"/>
+            <a:off x="406390" y="511067"/>
             <a:ext cx="11378915" cy="446980"/>
           </a:xfrm>
           <a:prstGeom prst="rect">
@@ -20319,7 +20319,7 @@
         </p:nvSpPr>
         <p:spPr>
           <a:xfrm>
-            <a:off x="406390" y="2776041"/>
+            <a:off x="406390" y="1113036"/>
             <a:ext cx="3691341" cy="1156097"/>
           </a:xfrm>
           <a:prstGeom prst="roundRect">
@@ -20341,7 +20341,7 @@
         </p:nvSpPr>
         <p:spPr>
           <a:xfrm>
-            <a:off x="558786" y="2928441"/>
+            <a:off x="558786" y="1265436"/>
             <a:ext cx="3386549" cy="851297"/>
           </a:xfrm>
           <a:prstGeom prst="rect">
@@ -20406,7 +20406,7 @@
         </p:nvSpPr>
         <p:spPr>
           <a:xfrm>
-            <a:off x="4250127" y="2776041"/>
+            <a:off x="4250127" y="1113036"/>
             <a:ext cx="3691341" cy="1156097"/>
           </a:xfrm>
           <a:prstGeom prst="roundRect">
@@ -20428,7 +20428,7 @@
         </p:nvSpPr>
         <p:spPr>
           <a:xfrm>
-            <a:off x="4402523" y="2928441"/>
+            <a:off x="4402523" y="1265436"/>
             <a:ext cx="3386549" cy="851297"/>
           </a:xfrm>
           <a:prstGeom prst="rect">
@@ -20493,7 +20493,7 @@
         </p:nvSpPr>
         <p:spPr>
           <a:xfrm>
-            <a:off x="8093865" y="2776041"/>
+            <a:off x="8093865" y="1113036"/>
             <a:ext cx="3691341" cy="1156097"/>
           </a:xfrm>
           <a:prstGeom prst="roundRect">
@@ -20515,7 +20515,7 @@
         </p:nvSpPr>
         <p:spPr>
           <a:xfrm>
-            <a:off x="8246261" y="2928441"/>
+            <a:off x="8246261" y="1265436"/>
             <a:ext cx="3386549" cy="851297"/>
           </a:xfrm>
           <a:prstGeom prst="rect">
@@ -20580,7 +20580,7 @@
         </p:nvSpPr>
         <p:spPr>
           <a:xfrm>
-            <a:off x="406390" y="4059138"/>
+            <a:off x="406390" y="2396133"/>
             <a:ext cx="11378915" cy="907256"/>
           </a:xfrm>
           <a:prstGeom prst="roundRect">
@@ -20602,7 +20602,7 @@
         </p:nvSpPr>
         <p:spPr>
           <a:xfrm>
-            <a:off x="558786" y="4211538"/>
+            <a:off x="558786" y="2548533"/>
             <a:ext cx="11074123" cy="602456"/>
           </a:xfrm>
           <a:prstGeom prst="rect">
@@ -20765,7 +20765,7 @@
         </p:nvSpPr>
         <p:spPr>
           <a:xfrm>
-            <a:off x="406390" y="1601580"/>
+            <a:off x="406390" y="276811"/>
             <a:ext cx="11378915" cy="446980"/>
           </a:xfrm>
           <a:prstGeom prst="rect">
@@ -20807,7 +20807,7 @@
         </p:nvSpPr>
         <p:spPr>
           <a:xfrm>
-            <a:off x="406390" y="2212757"/>
+            <a:off x="406390" y="887988"/>
             <a:ext cx="11785305" cy="248841"/>
           </a:xfrm>
           <a:prstGeom prst="rect">
@@ -20856,7 +20856,7 @@
           </p:nvPr>
         </p:nvGraphicFramePr>
         <p:xfrm>
-          <a:off x="406390" y="2611140"/>
+          <a:off x="406390" y="1286371"/>
           <a:ext cx="4798793" cy="914400"/>
         </p:xfrm>
         <a:graphic>
@@ -21289,7 +21289,7 @@
         </p:nvSpPr>
         <p:spPr>
           <a:xfrm>
-            <a:off x="5509876" y="2620347"/>
+            <a:off x="5509876" y="1295579"/>
             <a:ext cx="6275429" cy="497681"/>
           </a:xfrm>
           <a:prstGeom prst="rect">
@@ -21333,7 +21333,7 @@
         </p:nvSpPr>
         <p:spPr>
           <a:xfrm>
-            <a:off x="5509876" y="3308846"/>
+            <a:off x="5509876" y="1984077"/>
             <a:ext cx="6275429" cy="924520"/>
           </a:xfrm>
           <a:prstGeom prst="roundRect">
@@ -21355,7 +21355,7 @@
         </p:nvSpPr>
         <p:spPr>
           <a:xfrm>
-            <a:off x="5723191" y="3486964"/>
+            <a:off x="5723191" y="2162195"/>
             <a:ext cx="5848799" cy="568920"/>
           </a:xfrm>
           <a:prstGeom prst="rect">
@@ -21419,7 +21419,7 @@
         </p:nvSpPr>
         <p:spPr>
           <a:xfrm>
-            <a:off x="406390" y="4585791"/>
+            <a:off x="406390" y="3261023"/>
             <a:ext cx="11378915" cy="693341"/>
           </a:xfrm>
           <a:prstGeom prst="roundRect">
@@ -21449,7 +21449,7 @@
         </p:blipFill>
         <p:spPr>
           <a:xfrm>
-            <a:off x="584185" y="4842966"/>
+            <a:off x="584185" y="3518198"/>
             <a:ext cx="222244" cy="177800"/>
           </a:xfrm>
           <a:prstGeom prst="rect">
@@ -21465,7 +21465,7 @@
         </p:nvSpPr>
         <p:spPr>
           <a:xfrm>
-            <a:off x="984225" y="4817249"/>
+            <a:off x="984225" y="3492480"/>
             <a:ext cx="11207470" cy="248841"/>
           </a:xfrm>
           <a:prstGeom prst="rect">
@@ -21605,7 +21605,7 @@
         </p:nvSpPr>
         <p:spPr>
           <a:xfrm>
-            <a:off x="406390" y="1762780"/>
+            <a:off x="406390" y="259715"/>
             <a:ext cx="11785305" cy="186630"/>
           </a:xfrm>
           <a:prstGeom prst="rect">
@@ -21647,7 +21647,7 @@
         </p:nvSpPr>
         <p:spPr>
           <a:xfrm>
-            <a:off x="406390" y="2039532"/>
+            <a:off x="406390" y="536467"/>
             <a:ext cx="11378915" cy="446980"/>
           </a:xfrm>
           <a:prstGeom prst="rect">
@@ -21689,7 +21689,7 @@
         </p:nvSpPr>
         <p:spPr>
           <a:xfrm>
-            <a:off x="406390" y="2650708"/>
+            <a:off x="406390" y="1147644"/>
             <a:ext cx="11785305" cy="248841"/>
           </a:xfrm>
           <a:prstGeom prst="rect">
@@ -21731,7 +21731,7 @@
         </p:nvSpPr>
         <p:spPr>
           <a:xfrm>
-            <a:off x="406390" y="3042741"/>
+            <a:off x="406390" y="1539677"/>
             <a:ext cx="3589744" cy="2058194"/>
           </a:xfrm>
           <a:prstGeom prst="roundRect">
@@ -21753,7 +21753,7 @@
         </p:nvSpPr>
         <p:spPr>
           <a:xfrm>
-            <a:off x="584185" y="3220541"/>
+            <a:off x="584185" y="1717477"/>
             <a:ext cx="3234153" cy="1702594"/>
           </a:xfrm>
           <a:prstGeom prst="rect">
@@ -21841,7 +21841,7 @@
         </p:nvSpPr>
         <p:spPr>
           <a:xfrm>
-            <a:off x="4300926" y="3042741"/>
+            <a:off x="4300926" y="1539677"/>
             <a:ext cx="3589744" cy="2058194"/>
           </a:xfrm>
           <a:prstGeom prst="roundRect">
@@ -21863,7 +21863,7 @@
         </p:nvSpPr>
         <p:spPr>
           <a:xfrm>
-            <a:off x="4478722" y="3220541"/>
+            <a:off x="4478722" y="1717477"/>
             <a:ext cx="3234153" cy="1702594"/>
           </a:xfrm>
           <a:prstGeom prst="rect">
@@ -21951,7 +21951,7 @@
         </p:nvSpPr>
         <p:spPr>
           <a:xfrm>
-            <a:off x="8195462" y="3042741"/>
+            <a:off x="8195462" y="1539677"/>
             <a:ext cx="3589744" cy="2058194"/>
           </a:xfrm>
           <a:prstGeom prst="roundRect">
@@ -21973,7 +21973,7 @@
         </p:nvSpPr>
         <p:spPr>
           <a:xfrm>
-            <a:off x="8373258" y="3220541"/>
+            <a:off x="8373258" y="1717477"/>
             <a:ext cx="3234153" cy="1702594"/>
           </a:xfrm>
           <a:prstGeom prst="rect">
@@ -22159,7 +22159,7 @@
         </p:nvSpPr>
         <p:spPr>
           <a:xfrm>
-            <a:off x="406390" y="1772900"/>
+            <a:off x="406390" y="234315"/>
             <a:ext cx="11785305" cy="186630"/>
           </a:xfrm>
           <a:prstGeom prst="rect">
@@ -22201,7 +22201,7 @@
         </p:nvSpPr>
         <p:spPr>
           <a:xfrm>
-            <a:off x="406390" y="2049652"/>
+            <a:off x="406390" y="511067"/>
             <a:ext cx="11378915" cy="446980"/>
           </a:xfrm>
           <a:prstGeom prst="rect">
@@ -22243,7 +22243,7 @@
         </p:nvSpPr>
         <p:spPr>
           <a:xfrm>
-            <a:off x="406390" y="2651621"/>
+            <a:off x="406390" y="1113036"/>
             <a:ext cx="3691341" cy="1404938"/>
           </a:xfrm>
           <a:prstGeom prst="roundRect">
@@ -22265,7 +22265,7 @@
         </p:nvSpPr>
         <p:spPr>
           <a:xfrm>
-            <a:off x="558786" y="2804021"/>
+            <a:off x="558786" y="1265436"/>
             <a:ext cx="3386549" cy="851297"/>
           </a:xfrm>
           <a:prstGeom prst="rect">
@@ -22330,7 +22330,7 @@
         </p:nvSpPr>
         <p:spPr>
           <a:xfrm>
-            <a:off x="4250127" y="2651621"/>
+            <a:off x="4250127" y="1113036"/>
             <a:ext cx="3691341" cy="1404938"/>
           </a:xfrm>
           <a:prstGeom prst="roundRect">
@@ -22352,7 +22352,7 @@
         </p:nvSpPr>
         <p:spPr>
           <a:xfrm>
-            <a:off x="4402523" y="2804021"/>
+            <a:off x="4402523" y="1265436"/>
             <a:ext cx="3386549" cy="1100138"/>
           </a:xfrm>
           <a:prstGeom prst="rect">
@@ -22417,7 +22417,7 @@
         </p:nvSpPr>
         <p:spPr>
           <a:xfrm>
-            <a:off x="8093865" y="2651621"/>
+            <a:off x="8093865" y="1113036"/>
             <a:ext cx="3691341" cy="1404938"/>
           </a:xfrm>
           <a:prstGeom prst="roundRect">
@@ -22439,7 +22439,7 @@
         </p:nvSpPr>
         <p:spPr>
           <a:xfrm>
-            <a:off x="8246261" y="2804021"/>
+            <a:off x="8246261" y="1265436"/>
             <a:ext cx="3386549" cy="851297"/>
           </a:xfrm>
           <a:prstGeom prst="rect">
@@ -22504,7 +22504,7 @@
         </p:nvSpPr>
         <p:spPr>
           <a:xfrm>
-            <a:off x="406390" y="4183559"/>
+            <a:off x="406390" y="2644973"/>
             <a:ext cx="11378915" cy="907256"/>
           </a:xfrm>
           <a:prstGeom prst="roundRect">
@@ -22526,7 +22526,7 @@
         </p:nvSpPr>
         <p:spPr>
           <a:xfrm>
-            <a:off x="558786" y="4335959"/>
+            <a:off x="558786" y="2797373"/>
             <a:ext cx="11074123" cy="602456"/>
           </a:xfrm>
           <a:prstGeom prst="rect">
@@ -22689,7 +22689,7 @@
         </p:nvSpPr>
         <p:spPr>
           <a:xfrm>
-            <a:off x="406390" y="1638360"/>
+            <a:off x="406390" y="259715"/>
             <a:ext cx="11785305" cy="186630"/>
           </a:xfrm>
           <a:prstGeom prst="rect">
@@ -22731,7 +22731,7 @@
         </p:nvSpPr>
         <p:spPr>
           <a:xfrm>
-            <a:off x="406390" y="1915111"/>
+            <a:off x="406390" y="536467"/>
             <a:ext cx="11378915" cy="446980"/>
           </a:xfrm>
           <a:prstGeom prst="rect">
@@ -22773,7 +22773,7 @@
         </p:nvSpPr>
         <p:spPr>
           <a:xfrm>
-            <a:off x="406390" y="2526288"/>
+            <a:off x="406390" y="1147644"/>
             <a:ext cx="11785305" cy="248841"/>
           </a:xfrm>
           <a:prstGeom prst="rect">
@@ -22815,7 +22815,7 @@
         </p:nvSpPr>
         <p:spPr>
           <a:xfrm>
-            <a:off x="406390" y="2918321"/>
+            <a:off x="406390" y="1539677"/>
             <a:ext cx="3589744" cy="2307034"/>
           </a:xfrm>
           <a:prstGeom prst="roundRect">
@@ -22837,7 +22837,7 @@
         </p:nvSpPr>
         <p:spPr>
           <a:xfrm>
-            <a:off x="584185" y="3096121"/>
+            <a:off x="584185" y="1717477"/>
             <a:ext cx="3234153" cy="1702594"/>
           </a:xfrm>
           <a:prstGeom prst="rect">
@@ -22925,7 +22925,7 @@
         </p:nvSpPr>
         <p:spPr>
           <a:xfrm>
-            <a:off x="4300926" y="2918321"/>
+            <a:off x="4300926" y="1539677"/>
             <a:ext cx="3589744" cy="2307034"/>
           </a:xfrm>
           <a:prstGeom prst="roundRect">
@@ -22947,7 +22947,7 @@
         </p:nvSpPr>
         <p:spPr>
           <a:xfrm>
-            <a:off x="4478722" y="3096121"/>
+            <a:off x="4478722" y="1717477"/>
             <a:ext cx="3234153" cy="1951434"/>
           </a:xfrm>
           <a:prstGeom prst="rect">
@@ -23035,7 +23035,7 @@
         </p:nvSpPr>
         <p:spPr>
           <a:xfrm>
-            <a:off x="8195462" y="2918321"/>
+            <a:off x="8195462" y="1539677"/>
             <a:ext cx="3589744" cy="2307034"/>
           </a:xfrm>
           <a:prstGeom prst="roundRect">
@@ -23057,7 +23057,7 @@
         </p:nvSpPr>
         <p:spPr>
           <a:xfrm>
-            <a:off x="8373258" y="3096121"/>
+            <a:off x="8373258" y="1717477"/>
             <a:ext cx="3234153" cy="1702594"/>
           </a:xfrm>
           <a:prstGeom prst="rect">
@@ -23243,7 +23243,7 @@
         </p:nvSpPr>
         <p:spPr>
           <a:xfrm>
-            <a:off x="406390" y="1833820"/>
+            <a:off x="406390" y="259715"/>
             <a:ext cx="11785305" cy="186630"/>
           </a:xfrm>
           <a:prstGeom prst="rect">
@@ -23285,7 +23285,7 @@
         </p:nvSpPr>
         <p:spPr>
           <a:xfrm>
-            <a:off x="406390" y="2110572"/>
+            <a:off x="406390" y="536467"/>
             <a:ext cx="11378915" cy="446980"/>
           </a:xfrm>
           <a:prstGeom prst="rect">
@@ -23327,7 +23327,7 @@
         </p:nvSpPr>
         <p:spPr>
           <a:xfrm>
-            <a:off x="406390" y="2712541"/>
+            <a:off x="406390" y="1138436"/>
             <a:ext cx="5537061" cy="1206897"/>
           </a:xfrm>
           <a:prstGeom prst="roundRect">
@@ -23349,7 +23349,7 @@
         </p:nvSpPr>
         <p:spPr>
           <a:xfrm>
-            <a:off x="584185" y="2890341"/>
+            <a:off x="584185" y="1316236"/>
             <a:ext cx="5181470" cy="851297"/>
           </a:xfrm>
           <a:prstGeom prst="rect">
@@ -23414,7 +23414,7 @@
         </p:nvSpPr>
         <p:spPr>
           <a:xfrm>
-            <a:off x="6248244" y="2712541"/>
+            <a:off x="6248244" y="1138436"/>
             <a:ext cx="5537061" cy="1206897"/>
           </a:xfrm>
           <a:prstGeom prst="roundRect">
@@ -23436,7 +23436,7 @@
         </p:nvSpPr>
         <p:spPr>
           <a:xfrm>
-            <a:off x="6426039" y="2890341"/>
+            <a:off x="6426039" y="1316236"/>
             <a:ext cx="5181470" cy="851297"/>
           </a:xfrm>
           <a:prstGeom prst="rect">
@@ -23501,7 +23501,7 @@
         </p:nvSpPr>
         <p:spPr>
           <a:xfrm>
-            <a:off x="406390" y="4071838"/>
+            <a:off x="406390" y="2497733"/>
             <a:ext cx="11378915" cy="958056"/>
           </a:xfrm>
           <a:prstGeom prst="roundRect">
@@ -23523,7 +23523,7 @@
         </p:nvSpPr>
         <p:spPr>
           <a:xfrm>
-            <a:off x="584185" y="4249638"/>
+            <a:off x="584185" y="2675533"/>
             <a:ext cx="11023324" cy="602456"/>
           </a:xfrm>
           <a:prstGeom prst="rect">
@@ -23686,7 +23686,7 @@
         </p:nvSpPr>
         <p:spPr>
           <a:xfrm>
-            <a:off x="406390" y="1583026"/>
+            <a:off x="406390" y="276811"/>
             <a:ext cx="11378915" cy="446980"/>
           </a:xfrm>
           <a:prstGeom prst="rect">
@@ -23735,7 +23735,7 @@
           </p:nvPr>
         </p:nvGraphicFramePr>
         <p:xfrm>
-          <a:off x="406390" y="2184995"/>
+          <a:off x="406390" y="878780"/>
           <a:ext cx="5906146" cy="914400"/>
         </p:xfrm>
         <a:graphic>
@@ -25722,7 +25722,7 @@
         </p:nvSpPr>
         <p:spPr>
           <a:xfrm>
-            <a:off x="6617229" y="2763639"/>
+            <a:off x="6617229" y="1457424"/>
             <a:ext cx="5168076" cy="1084263"/>
           </a:xfrm>
           <a:prstGeom prst="rect">
@@ -25809,7 +25809,7 @@
         </p:nvSpPr>
         <p:spPr>
           <a:xfrm>
-            <a:off x="406390" y="4604345"/>
+            <a:off x="406390" y="3298130"/>
             <a:ext cx="11378915" cy="693341"/>
           </a:xfrm>
           <a:prstGeom prst="roundRect">
@@ -25839,7 +25839,7 @@
         </p:blipFill>
         <p:spPr>
           <a:xfrm>
-            <a:off x="584185" y="4861520"/>
+            <a:off x="584185" y="3555305"/>
             <a:ext cx="222244" cy="177800"/>
           </a:xfrm>
           <a:prstGeom prst="rect">
@@ -25855,7 +25855,7 @@
         </p:nvSpPr>
         <p:spPr>
           <a:xfrm>
-            <a:off x="984225" y="4835803"/>
+            <a:off x="984225" y="3529588"/>
             <a:ext cx="11207470" cy="248841"/>
           </a:xfrm>
           <a:prstGeom prst="rect">
@@ -25995,7 +25995,7 @@
         </p:nvSpPr>
         <p:spPr>
           <a:xfrm>
-            <a:off x="406390" y="1732053"/>
+            <a:off x="406390" y="276811"/>
             <a:ext cx="11378915" cy="446980"/>
           </a:xfrm>
           <a:prstGeom prst="rect">
@@ -26037,7 +26037,7 @@
         </p:nvSpPr>
         <p:spPr>
           <a:xfrm>
-            <a:off x="406390" y="2334022"/>
+            <a:off x="406390" y="878780"/>
             <a:ext cx="11378915" cy="656431"/>
           </a:xfrm>
           <a:prstGeom prst="rect">
@@ -26109,7 +26109,7 @@
           </p:nvPr>
         </p:nvGraphicFramePr>
         <p:xfrm>
-          <a:off x="406390" y="3117453"/>
+          <a:off x="406390" y="1662212"/>
           <a:ext cx="11378916" cy="914400"/>
         </p:xfrm>
         <a:graphic>
@@ -26528,7 +26528,7 @@
         </p:nvSpPr>
         <p:spPr>
           <a:xfrm>
-            <a:off x="406390" y="4455319"/>
+            <a:off x="406390" y="3000077"/>
             <a:ext cx="11378915" cy="693341"/>
           </a:xfrm>
           <a:prstGeom prst="roundRect">
@@ -26558,7 +26558,7 @@
         </p:blipFill>
         <p:spPr>
           <a:xfrm>
-            <a:off x="584185" y="4712494"/>
+            <a:off x="584185" y="3257252"/>
             <a:ext cx="222244" cy="177800"/>
           </a:xfrm>
           <a:prstGeom prst="rect">
@@ -26574,7 +26574,7 @@
         </p:nvSpPr>
         <p:spPr>
           <a:xfrm>
-            <a:off x="984225" y="4686776"/>
+            <a:off x="984225" y="3231535"/>
             <a:ext cx="11207470" cy="248841"/>
           </a:xfrm>
           <a:prstGeom prst="rect">
@@ -26714,7 +26714,7 @@
         </p:nvSpPr>
         <p:spPr>
           <a:xfrm>
-            <a:off x="406390" y="1663195"/>
+            <a:off x="406390" y="276811"/>
             <a:ext cx="11378915" cy="446980"/>
           </a:xfrm>
           <a:prstGeom prst="rect">
@@ -26756,7 +26756,7 @@
         </p:nvSpPr>
         <p:spPr>
           <a:xfrm>
-            <a:off x="406390" y="2274372"/>
+            <a:off x="406390" y="887988"/>
             <a:ext cx="5537061" cy="497681"/>
           </a:xfrm>
           <a:prstGeom prst="rect">
@@ -26800,7 +26800,7 @@
         </p:nvSpPr>
         <p:spPr>
           <a:xfrm>
-            <a:off x="406390" y="2962870"/>
+            <a:off x="406390" y="1576487"/>
             <a:ext cx="5537061" cy="1208980"/>
           </a:xfrm>
           <a:prstGeom prst="roundRect">
@@ -26822,7 +26822,7 @@
         </p:nvSpPr>
         <p:spPr>
           <a:xfrm>
-            <a:off x="619705" y="3140988"/>
+            <a:off x="619705" y="1754604"/>
             <a:ext cx="5110432" cy="853380"/>
           </a:xfrm>
           <a:prstGeom prst="rect">
@@ -26906,7 +26906,7 @@
         </p:nvSpPr>
         <p:spPr>
           <a:xfrm>
-            <a:off x="6248244" y="2274372"/>
+            <a:off x="6248244" y="887988"/>
             <a:ext cx="5537061" cy="248841"/>
           </a:xfrm>
           <a:prstGeom prst="rect">
@@ -26948,7 +26948,7 @@
         </p:nvSpPr>
         <p:spPr>
           <a:xfrm>
-            <a:off x="6248244" y="2714030"/>
+            <a:off x="6248244" y="1327646"/>
             <a:ext cx="5537061" cy="924520"/>
           </a:xfrm>
           <a:prstGeom prst="roundRect">
@@ -26970,7 +26970,7 @@
         </p:nvSpPr>
         <p:spPr>
           <a:xfrm>
-            <a:off x="6461559" y="2892147"/>
+            <a:off x="6461559" y="1505764"/>
             <a:ext cx="5110432" cy="568920"/>
           </a:xfrm>
           <a:prstGeom prst="rect">
@@ -27014,7 +27014,7 @@
         </p:nvSpPr>
         <p:spPr>
           <a:xfrm>
-            <a:off x="406390" y="4524276"/>
+            <a:off x="406390" y="3137892"/>
             <a:ext cx="11378915" cy="693341"/>
           </a:xfrm>
           <a:prstGeom prst="roundRect">
@@ -27044,7 +27044,7 @@
         </p:blipFill>
         <p:spPr>
           <a:xfrm>
-            <a:off x="584185" y="4781451"/>
+            <a:off x="584185" y="3395067"/>
             <a:ext cx="222244" cy="177800"/>
           </a:xfrm>
           <a:prstGeom prst="rect">
@@ -27060,7 +27060,7 @@
         </p:nvSpPr>
         <p:spPr>
           <a:xfrm>
-            <a:off x="984225" y="4755733"/>
+            <a:off x="984225" y="3369350"/>
             <a:ext cx="11207470" cy="248841"/>
           </a:xfrm>
           <a:prstGeom prst="rect">
@@ -27200,7 +27200,7 @@
         </p:nvSpPr>
         <p:spPr>
           <a:xfrm>
-            <a:off x="406390" y="1443922"/>
+            <a:off x="406390" y="276811"/>
             <a:ext cx="11378915" cy="446980"/>
           </a:xfrm>
           <a:prstGeom prst="rect">
@@ -27242,7 +27242,7 @@
         </p:nvSpPr>
         <p:spPr>
           <a:xfrm>
-            <a:off x="406390" y="2045891"/>
+            <a:off x="406390" y="878780"/>
             <a:ext cx="11378915" cy="835422"/>
           </a:xfrm>
           <a:prstGeom prst="rect">
@@ -27339,7 +27339,7 @@
           </p:nvPr>
         </p:nvGraphicFramePr>
         <p:xfrm>
-          <a:off x="406390" y="3008313"/>
+          <a:off x="406390" y="1841202"/>
           <a:ext cx="11378916" cy="914400"/>
         </p:xfrm>
         <a:graphic>
@@ -27890,7 +27890,7 @@
         </p:nvSpPr>
         <p:spPr>
           <a:xfrm>
-            <a:off x="406390" y="4743450"/>
+            <a:off x="406390" y="3576340"/>
             <a:ext cx="11378915" cy="693341"/>
           </a:xfrm>
           <a:prstGeom prst="roundRect">
@@ -27920,7 +27920,7 @@
         </p:blipFill>
         <p:spPr>
           <a:xfrm>
-            <a:off x="584185" y="5000625"/>
+            <a:off x="584185" y="3833515"/>
             <a:ext cx="222244" cy="177800"/>
           </a:xfrm>
           <a:prstGeom prst="rect">
@@ -27936,7 +27936,7 @@
         </p:nvSpPr>
         <p:spPr>
           <a:xfrm>
-            <a:off x="984225" y="4974908"/>
+            <a:off x="984225" y="3807797"/>
             <a:ext cx="11207470" cy="248841"/>
           </a:xfrm>
           <a:prstGeom prst="rect">
@@ -28076,7 +28076,7 @@
         </p:nvSpPr>
         <p:spPr>
           <a:xfrm>
-            <a:off x="406390" y="1470115"/>
+            <a:off x="406390" y="276811"/>
             <a:ext cx="11378915" cy="446980"/>
           </a:xfrm>
           <a:prstGeom prst="rect">
@@ -28118,7 +28118,7 @@
         </p:nvSpPr>
         <p:spPr>
           <a:xfrm>
-            <a:off x="406390" y="2272109"/>
+            <a:off x="406390" y="1078805"/>
             <a:ext cx="5167977" cy="1208980"/>
           </a:xfrm>
           <a:prstGeom prst="roundRect">
@@ -28140,7 +28140,7 @@
         </p:nvSpPr>
         <p:spPr>
           <a:xfrm>
-            <a:off x="619705" y="2450227"/>
+            <a:off x="619705" y="1256923"/>
             <a:ext cx="4741347" cy="853380"/>
           </a:xfrm>
           <a:prstGeom prst="rect">
@@ -28224,7 +28224,7 @@
         </p:nvSpPr>
         <p:spPr>
           <a:xfrm>
-            <a:off x="5879060" y="2272109"/>
+            <a:off x="5879060" y="1078805"/>
             <a:ext cx="5906245" cy="1493441"/>
           </a:xfrm>
           <a:prstGeom prst="roundRect">
@@ -28246,7 +28246,7 @@
         </p:nvSpPr>
         <p:spPr>
           <a:xfrm>
-            <a:off x="6092375" y="2450227"/>
+            <a:off x="6092375" y="1256923"/>
             <a:ext cx="5479615" cy="1137841"/>
           </a:xfrm>
           <a:prstGeom prst="rect">
@@ -28350,7 +28350,7 @@
         </p:nvSpPr>
         <p:spPr>
           <a:xfrm>
-            <a:off x="406390" y="4101783"/>
+            <a:off x="406390" y="2908479"/>
             <a:ext cx="11378915" cy="497681"/>
           </a:xfrm>
           <a:prstGeom prst="rect">
@@ -28394,7 +28394,7 @@
         </p:nvSpPr>
         <p:spPr>
           <a:xfrm>
-            <a:off x="406390" y="4717256"/>
+            <a:off x="406390" y="3523952"/>
             <a:ext cx="11378915" cy="693341"/>
           </a:xfrm>
           <a:prstGeom prst="roundRect">
@@ -28424,7 +28424,7 @@
         </p:blipFill>
         <p:spPr>
           <a:xfrm>
-            <a:off x="584185" y="4974431"/>
+            <a:off x="584185" y="3781127"/>
             <a:ext cx="222244" cy="177800"/>
           </a:xfrm>
           <a:prstGeom prst="rect">
@@ -28440,7 +28440,7 @@
         </p:nvSpPr>
         <p:spPr>
           <a:xfrm>
-            <a:off x="984225" y="4948714"/>
+            <a:off x="984225" y="3755410"/>
             <a:ext cx="11207470" cy="248841"/>
           </a:xfrm>
           <a:prstGeom prst="rect">
@@ -28580,7 +28580,7 @@
         </p:nvSpPr>
         <p:spPr>
           <a:xfrm>
-            <a:off x="406390" y="1627575"/>
+            <a:off x="406390" y="276811"/>
             <a:ext cx="11378915" cy="446980"/>
           </a:xfrm>
           <a:prstGeom prst="rect">
@@ -28622,7 +28622,7 @@
         </p:nvSpPr>
         <p:spPr>
           <a:xfrm>
-            <a:off x="406390" y="2429570"/>
+            <a:off x="406390" y="1078805"/>
             <a:ext cx="5906146" cy="1777901"/>
           </a:xfrm>
           <a:prstGeom prst="roundRect">
@@ -28644,7 +28644,7 @@
         </p:nvSpPr>
         <p:spPr>
           <a:xfrm>
-            <a:off x="619705" y="2607687"/>
+            <a:off x="619705" y="1256923"/>
             <a:ext cx="5479516" cy="1422301"/>
           </a:xfrm>
           <a:prstGeom prst="rect">
@@ -28768,7 +28768,7 @@
         </p:nvSpPr>
         <p:spPr>
           <a:xfrm>
-            <a:off x="6617229" y="2433717"/>
+            <a:off x="6617229" y="1082953"/>
             <a:ext cx="5168076" cy="248841"/>
           </a:xfrm>
           <a:prstGeom prst="rect">
@@ -28817,7 +28817,7 @@
           </p:nvPr>
         </p:nvGraphicFramePr>
         <p:xfrm>
-          <a:off x="6617229" y="2778125"/>
+          <a:off x="6617229" y="1427361"/>
           <a:ext cx="5168076" cy="914400"/>
         </p:xfrm>
         <a:graphic>
@@ -29250,7 +29250,7 @@
         </p:nvSpPr>
         <p:spPr>
           <a:xfrm>
-            <a:off x="406390" y="4559895"/>
+            <a:off x="406390" y="3209131"/>
             <a:ext cx="11378915" cy="693341"/>
           </a:xfrm>
           <a:prstGeom prst="roundRect">
@@ -29280,7 +29280,7 @@
         </p:blipFill>
         <p:spPr>
           <a:xfrm>
-            <a:off x="584185" y="4817070"/>
+            <a:off x="584185" y="3466306"/>
             <a:ext cx="222244" cy="177800"/>
           </a:xfrm>
           <a:prstGeom prst="rect">
@@ -29296,7 +29296,7 @@
         </p:nvSpPr>
         <p:spPr>
           <a:xfrm>
-            <a:off x="984225" y="4791353"/>
+            <a:off x="984225" y="3440589"/>
             <a:ext cx="11207470" cy="248841"/>
           </a:xfrm>
           <a:prstGeom prst="rect">

</xml_diff>